<commit_message>
enlarge presentation fonts for readability
Add a global font scale (1.18x for text < 24pt) applied in the text/bullets
helpers, raise helper defaults (cards, tables, source notes, footer), give
card titles more vertical room, and shorten the slide-6 Geely title to one line.

Co-Authored-By: Claude Opus 4.8 <noreply@anthropic.com>
</commit_message>
<xml_diff>
--- a/research/presentation/china-strategies-julia.pptx
+++ b/research/presentation/china-strategies-julia.pptx
@@ -5469,7 +5469,7 @@
               </a:spcAft>
             </a:pPr>
             <a:r>
-              <a:rPr sz="1300" b="1" i="0">
+              <a:rPr sz="1534" b="1" i="0">
                 <a:solidFill>
                   <a:srgbClr val="06B6D4"/>
                 </a:solidFill>
@@ -5581,7 +5581,7 @@
               </a:spcAft>
             </a:pPr>
             <a:r>
-              <a:rPr sz="1800" b="0" i="1">
+              <a:rPr sz="2124" b="0" i="1">
                 <a:solidFill>
                   <a:srgbClr val="CBD5E1"/>
                 </a:solidFill>
@@ -5670,7 +5670,7 @@
               </a:spcAft>
             </a:pPr>
             <a:r>
-              <a:rPr sz="1250" b="1" i="0">
+              <a:rPr sz="1475" b="1" i="0">
                 <a:solidFill>
                   <a:srgbClr val="FFFFFF"/>
                 </a:solidFill>
@@ -5759,7 +5759,7 @@
               </a:spcAft>
             </a:pPr>
             <a:r>
-              <a:rPr sz="1250" b="1" i="0">
+              <a:rPr sz="1475" b="1" i="0">
                 <a:solidFill>
                   <a:srgbClr val="FFFFFF"/>
                 </a:solidFill>
@@ -5848,7 +5848,7 @@
               </a:spcAft>
             </a:pPr>
             <a:r>
-              <a:rPr sz="1250" b="1" i="0">
+              <a:rPr sz="1475" b="1" i="0">
                 <a:solidFill>
                   <a:srgbClr val="FFFFFF"/>
                 </a:solidFill>
@@ -5893,7 +5893,7 @@
               </a:spcAft>
             </a:pPr>
             <a:r>
-              <a:rPr sz="1500" b="1" i="0">
+              <a:rPr sz="1770" b="1" i="0">
                 <a:solidFill>
                   <a:srgbClr val="FFFFFF"/>
                 </a:solidFill>
@@ -5938,7 +5938,7 @@
               </a:spcAft>
             </a:pPr>
             <a:r>
-              <a:rPr sz="1200" b="0" i="0">
+              <a:rPr sz="1416" b="0" i="0">
                 <a:solidFill>
                   <a:srgbClr val="64748B"/>
                 </a:solidFill>
@@ -5960,7 +5960,7 @@
               </a:spcAft>
             </a:pPr>
             <a:r>
-              <a:rPr sz="1200" b="0" i="0">
+              <a:rPr sz="1416" b="0" i="0">
                 <a:solidFill>
                   <a:srgbClr val="64748B"/>
                 </a:solidFill>
@@ -6067,7 +6067,7 @@
               </a:spcAft>
             </a:pPr>
             <a:r>
-              <a:rPr sz="1250" b="1" i="0">
+              <a:rPr sz="1652" b="1" i="0">
                 <a:solidFill>
                   <a:srgbClr val="2563EB"/>
                 </a:solidFill>
@@ -6222,7 +6222,7 @@
         <p:spPr>
           <a:xfrm>
             <a:off x="713232" y="1892808"/>
-            <a:ext cx="3264408" cy="365760"/>
+            <a:ext cx="3264408" cy="548640"/>
           </a:xfrm>
           <a:prstGeom prst="rect">
             <a:avLst/>
@@ -6237,7 +6237,7 @@
           <a:p>
             <a:pPr algn="l">
               <a:lnSpc>
-                <a:spcPct val="100000"/>
+                <a:spcPct val="98000"/>
               </a:lnSpc>
               <a:spcBef>
                 <a:spcPts val="0"/>
@@ -6247,7 +6247,7 @@
               </a:spcAft>
             </a:pPr>
             <a:r>
-              <a:rPr sz="1500" b="1" i="0">
+              <a:rPr sz="1888" b="1" i="0">
                 <a:solidFill>
                   <a:srgbClr val="DC2626"/>
                 </a:solidFill>
@@ -6266,8 +6266,8 @@
         </p:nvSpPr>
         <p:spPr>
           <a:xfrm>
-            <a:off x="713232" y="2350008"/>
-            <a:ext cx="3264408" cy="3017520"/>
+            <a:off x="713232" y="2478024"/>
+            <a:ext cx="3264408" cy="2889504"/>
           </a:xfrm>
           <a:prstGeom prst="rect">
             <a:avLst/>
@@ -6292,7 +6292,7 @@
               </a:spcAft>
             </a:pPr>
             <a:r>
-              <a:rPr sz="1150" b="0">
+              <a:rPr sz="1534" b="0">
                 <a:solidFill>
                   <a:srgbClr val="DC2626"/>
                 </a:solidFill>
@@ -6301,7 +6301,7 @@
               <a:t>–  </a:t>
             </a:r>
             <a:r>
-              <a:rPr sz="1150">
+              <a:rPr sz="1534">
                 <a:solidFill>
                   <a:srgbClr val="0F172A"/>
                 </a:solidFill>
@@ -6323,7 +6323,7 @@
               </a:spcAft>
             </a:pPr>
             <a:r>
-              <a:rPr sz="1150" b="0">
+              <a:rPr sz="1534" b="0">
                 <a:solidFill>
                   <a:srgbClr val="DC2626"/>
                 </a:solidFill>
@@ -6332,7 +6332,7 @@
               <a:t>–  </a:t>
             </a:r>
             <a:r>
-              <a:rPr sz="1150">
+              <a:rPr sz="1534">
                 <a:solidFill>
                   <a:srgbClr val="0F172A"/>
                 </a:solidFill>
@@ -6354,7 +6354,7 @@
               </a:spcAft>
             </a:pPr>
             <a:r>
-              <a:rPr sz="1150" b="0">
+              <a:rPr sz="1534" b="0">
                 <a:solidFill>
                   <a:srgbClr val="DC2626"/>
                 </a:solidFill>
@@ -6363,7 +6363,7 @@
               <a:t>–  </a:t>
             </a:r>
             <a:r>
-              <a:rPr sz="1150">
+              <a:rPr sz="1534">
                 <a:solidFill>
                   <a:srgbClr val="0F172A"/>
                 </a:solidFill>
@@ -6385,7 +6385,7 @@
               </a:spcAft>
             </a:pPr>
             <a:r>
-              <a:rPr sz="1150" b="0">
+              <a:rPr sz="1534" b="0">
                 <a:solidFill>
                   <a:srgbClr val="DC2626"/>
                 </a:solidFill>
@@ -6394,7 +6394,7 @@
               <a:t>–  </a:t>
             </a:r>
             <a:r>
-              <a:rPr sz="1150">
+              <a:rPr sz="1534">
                 <a:solidFill>
                   <a:srgbClr val="0F172A"/>
                 </a:solidFill>
@@ -6416,7 +6416,7 @@
               </a:spcAft>
             </a:pPr>
             <a:r>
-              <a:rPr sz="1150" b="0">
+              <a:rPr sz="1534" b="0">
                 <a:solidFill>
                   <a:srgbClr val="DC2626"/>
                 </a:solidFill>
@@ -6425,7 +6425,7 @@
               <a:t>–  </a:t>
             </a:r>
             <a:r>
-              <a:rPr sz="1150">
+              <a:rPr sz="1534">
                 <a:solidFill>
                   <a:srgbClr val="0F172A"/>
                 </a:solidFill>
@@ -6535,7 +6535,7 @@
         <p:spPr>
           <a:xfrm>
             <a:off x="4443984" y="1892808"/>
-            <a:ext cx="3264408" cy="365760"/>
+            <a:ext cx="3264408" cy="548640"/>
           </a:xfrm>
           <a:prstGeom prst="rect">
             <a:avLst/>
@@ -6550,7 +6550,7 @@
           <a:p>
             <a:pPr algn="l">
               <a:lnSpc>
-                <a:spcPct val="100000"/>
+                <a:spcPct val="98000"/>
               </a:lnSpc>
               <a:spcBef>
                 <a:spcPts val="0"/>
@@ -6560,7 +6560,7 @@
               </a:spcAft>
             </a:pPr>
             <a:r>
-              <a:rPr sz="1500" b="1" i="0">
+              <a:rPr sz="1888" b="1" i="0">
                 <a:solidFill>
                   <a:srgbClr val="2563EB"/>
                 </a:solidFill>
@@ -6579,8 +6579,8 @@
         </p:nvSpPr>
         <p:spPr>
           <a:xfrm>
-            <a:off x="4443984" y="2350008"/>
-            <a:ext cx="3264408" cy="3017520"/>
+            <a:off x="4443984" y="2478024"/>
+            <a:ext cx="3264408" cy="2889504"/>
           </a:xfrm>
           <a:prstGeom prst="rect">
             <a:avLst/>
@@ -6605,7 +6605,7 @@
               </a:spcAft>
             </a:pPr>
             <a:r>
-              <a:rPr sz="1150" b="0">
+              <a:rPr sz="1534" b="0">
                 <a:solidFill>
                   <a:srgbClr val="2563EB"/>
                 </a:solidFill>
@@ -6614,7 +6614,7 @@
               <a:t>–  </a:t>
             </a:r>
             <a:r>
-              <a:rPr sz="1150">
+              <a:rPr sz="1534">
                 <a:solidFill>
                   <a:srgbClr val="0F172A"/>
                 </a:solidFill>
@@ -6636,7 +6636,7 @@
               </a:spcAft>
             </a:pPr>
             <a:r>
-              <a:rPr sz="1150" b="0">
+              <a:rPr sz="1534" b="0">
                 <a:solidFill>
                   <a:srgbClr val="2563EB"/>
                 </a:solidFill>
@@ -6645,7 +6645,7 @@
               <a:t>–  </a:t>
             </a:r>
             <a:r>
-              <a:rPr sz="1150">
+              <a:rPr sz="1534">
                 <a:solidFill>
                   <a:srgbClr val="0F172A"/>
                 </a:solidFill>
@@ -6667,7 +6667,7 @@
               </a:spcAft>
             </a:pPr>
             <a:r>
-              <a:rPr sz="1150" b="0">
+              <a:rPr sz="1534" b="0">
                 <a:solidFill>
                   <a:srgbClr val="2563EB"/>
                 </a:solidFill>
@@ -6676,7 +6676,7 @@
               <a:t>–  </a:t>
             </a:r>
             <a:r>
-              <a:rPr sz="1150">
+              <a:rPr sz="1534">
                 <a:solidFill>
                   <a:srgbClr val="0F172A"/>
                 </a:solidFill>
@@ -6698,7 +6698,7 @@
               </a:spcAft>
             </a:pPr>
             <a:r>
-              <a:rPr sz="1150" b="0">
+              <a:rPr sz="1534" b="0">
                 <a:solidFill>
                   <a:srgbClr val="2563EB"/>
                 </a:solidFill>
@@ -6707,7 +6707,7 @@
               <a:t>–  </a:t>
             </a:r>
             <a:r>
-              <a:rPr sz="1150">
+              <a:rPr sz="1534">
                 <a:solidFill>
                   <a:srgbClr val="0F172A"/>
                 </a:solidFill>
@@ -6729,7 +6729,7 @@
               </a:spcAft>
             </a:pPr>
             <a:r>
-              <a:rPr sz="1150" b="0">
+              <a:rPr sz="1534" b="0">
                 <a:solidFill>
                   <a:srgbClr val="2563EB"/>
                 </a:solidFill>
@@ -6738,7 +6738,7 @@
               <a:t>–  </a:t>
             </a:r>
             <a:r>
-              <a:rPr sz="1150">
+              <a:rPr sz="1534">
                 <a:solidFill>
                   <a:srgbClr val="0F172A"/>
                 </a:solidFill>
@@ -6848,7 +6848,7 @@
         <p:spPr>
           <a:xfrm>
             <a:off x="8174736" y="1892808"/>
-            <a:ext cx="3264408" cy="365760"/>
+            <a:ext cx="3264408" cy="548640"/>
           </a:xfrm>
           <a:prstGeom prst="rect">
             <a:avLst/>
@@ -6863,7 +6863,7 @@
           <a:p>
             <a:pPr algn="l">
               <a:lnSpc>
-                <a:spcPct val="100000"/>
+                <a:spcPct val="98000"/>
               </a:lnSpc>
               <a:spcBef>
                 <a:spcPts val="0"/>
@@ -6873,7 +6873,7 @@
               </a:spcAft>
             </a:pPr>
             <a:r>
-              <a:rPr sz="1500" b="1" i="0">
+              <a:rPr sz="1888" b="1" i="0">
                 <a:solidFill>
                   <a:srgbClr val="06B6D4"/>
                 </a:solidFill>
@@ -6892,8 +6892,8 @@
         </p:nvSpPr>
         <p:spPr>
           <a:xfrm>
-            <a:off x="8174736" y="2350008"/>
-            <a:ext cx="3264408" cy="3017520"/>
+            <a:off x="8174736" y="2478024"/>
+            <a:ext cx="3264408" cy="2889504"/>
           </a:xfrm>
           <a:prstGeom prst="rect">
             <a:avLst/>
@@ -6918,7 +6918,7 @@
               </a:spcAft>
             </a:pPr>
             <a:r>
-              <a:rPr sz="1150" b="0">
+              <a:rPr sz="1534" b="0">
                 <a:solidFill>
                   <a:srgbClr val="06B6D4"/>
                 </a:solidFill>
@@ -6927,7 +6927,7 @@
               <a:t>–  </a:t>
             </a:r>
             <a:r>
-              <a:rPr sz="1150">
+              <a:rPr sz="1534">
                 <a:solidFill>
                   <a:srgbClr val="0F172A"/>
                 </a:solidFill>
@@ -6949,7 +6949,7 @@
               </a:spcAft>
             </a:pPr>
             <a:r>
-              <a:rPr sz="1150" b="0">
+              <a:rPr sz="1534" b="0">
                 <a:solidFill>
                   <a:srgbClr val="06B6D4"/>
                 </a:solidFill>
@@ -6958,7 +6958,7 @@
               <a:t>–  </a:t>
             </a:r>
             <a:r>
-              <a:rPr sz="1150">
+              <a:rPr sz="1534">
                 <a:solidFill>
                   <a:srgbClr val="0F172A"/>
                 </a:solidFill>
@@ -6980,7 +6980,7 @@
               </a:spcAft>
             </a:pPr>
             <a:r>
-              <a:rPr sz="1150" b="0">
+              <a:rPr sz="1534" b="0">
                 <a:solidFill>
                   <a:srgbClr val="06B6D4"/>
                 </a:solidFill>
@@ -6989,7 +6989,7 @@
               <a:t>–  </a:t>
             </a:r>
             <a:r>
-              <a:rPr sz="1150">
+              <a:rPr sz="1534">
                 <a:solidFill>
                   <a:srgbClr val="0F172A"/>
                 </a:solidFill>
@@ -7011,7 +7011,7 @@
               </a:spcAft>
             </a:pPr>
             <a:r>
-              <a:rPr sz="1150" b="0">
+              <a:rPr sz="1534" b="0">
                 <a:solidFill>
                   <a:srgbClr val="06B6D4"/>
                 </a:solidFill>
@@ -7020,7 +7020,7 @@
               <a:t>–  </a:t>
             </a:r>
             <a:r>
-              <a:rPr sz="1150">
+              <a:rPr sz="1534">
                 <a:solidFill>
                   <a:srgbClr val="0F172A"/>
                 </a:solidFill>
@@ -7042,7 +7042,7 @@
               </a:spcAft>
             </a:pPr>
             <a:r>
-              <a:rPr sz="1150" b="0">
+              <a:rPr sz="1534" b="0">
                 <a:solidFill>
                   <a:srgbClr val="06B6D4"/>
                 </a:solidFill>
@@ -7051,7 +7051,7 @@
               <a:t>–  </a:t>
             </a:r>
             <a:r>
-              <a:rPr sz="1150">
+              <a:rPr sz="1534">
                 <a:solidFill>
                   <a:srgbClr val="0F172A"/>
                 </a:solidFill>
@@ -7096,7 +7096,7 @@
               </a:spcAft>
             </a:pPr>
             <a:r>
-              <a:rPr sz="950" b="0" i="1">
+              <a:rPr sz="1297" b="0" i="1">
                 <a:solidFill>
                   <a:srgbClr val="64748B"/>
                 </a:solidFill>
@@ -7141,7 +7141,7 @@
               </a:spcAft>
             </a:pPr>
             <a:r>
-              <a:rPr sz="900" b="0" i="0">
+              <a:rPr sz="1238" b="0" i="0">
                 <a:solidFill>
                   <a:srgbClr val="64748B"/>
                 </a:solidFill>
@@ -7186,7 +7186,7 @@
               </a:spcAft>
             </a:pPr>
             <a:r>
-              <a:rPr sz="900" b="0" i="0">
+              <a:rPr sz="1238" b="0" i="0">
                 <a:solidFill>
                   <a:srgbClr val="64748B"/>
                 </a:solidFill>
@@ -7293,7 +7293,7 @@
               </a:spcAft>
             </a:pPr>
             <a:r>
-              <a:rPr sz="1250" b="1" i="0">
+              <a:rPr sz="1652" b="1" i="0">
                 <a:solidFill>
                   <a:srgbClr val="2563EB"/>
                 </a:solidFill>
@@ -7429,7 +7429,7 @@
               </a:spcAft>
             </a:pPr>
             <a:r>
-              <a:rPr sz="1100" b="1" i="0">
+              <a:rPr sz="1297" b="1" i="0">
                 <a:solidFill>
                   <a:srgbClr val="64748B"/>
                 </a:solidFill>
@@ -7474,7 +7474,7 @@
               </a:spcAft>
             </a:pPr>
             <a:r>
-              <a:rPr sz="1050" b="1" i="0">
+              <a:rPr sz="1238" b="1" i="0">
                 <a:solidFill>
                   <a:srgbClr val="64748B"/>
                 </a:solidFill>
@@ -7651,7 +7651,7 @@
               </a:spcAft>
             </a:pPr>
             <a:r>
-              <a:rPr sz="1250" b="1" i="0">
+              <a:rPr sz="1652" b="1" i="0">
                 <a:solidFill>
                   <a:srgbClr val="0F172A"/>
                 </a:solidFill>
@@ -7740,7 +7740,7 @@
               </a:spcAft>
             </a:pPr>
             <a:r>
-              <a:rPr sz="1250" b="1" i="0">
+              <a:rPr sz="1652" b="1" i="0">
                 <a:solidFill>
                   <a:srgbClr val="0F172A"/>
                 </a:solidFill>
@@ -7829,7 +7829,7 @@
               </a:spcAft>
             </a:pPr>
             <a:r>
-              <a:rPr sz="1250" b="1" i="0">
+              <a:rPr sz="1652" b="1" i="0">
                 <a:solidFill>
                   <a:srgbClr val="0F172A"/>
                 </a:solidFill>
@@ -7874,7 +7874,7 @@
               </a:spcAft>
             </a:pPr>
             <a:r>
-              <a:rPr sz="1000" b="0" i="1">
+              <a:rPr sz="1297" b="0" i="1">
                 <a:solidFill>
                   <a:srgbClr val="64748B"/>
                 </a:solidFill>
@@ -7919,7 +7919,7 @@
               </a:spcAft>
             </a:pPr>
             <a:r>
-              <a:rPr sz="1000" b="0" i="1">
+              <a:rPr sz="1297" b="0" i="1">
                 <a:solidFill>
                   <a:srgbClr val="64748B"/>
                 </a:solidFill>
@@ -7964,7 +7964,7 @@
               </a:spcAft>
             </a:pPr>
             <a:r>
-              <a:rPr sz="1000" b="0" i="1">
+              <a:rPr sz="1297" b="0" i="1">
                 <a:solidFill>
                   <a:srgbClr val="64748B"/>
                 </a:solidFill>
@@ -8009,7 +8009,7 @@
               </a:spcAft>
             </a:pPr>
             <a:r>
-              <a:rPr sz="1000" b="0" i="1">
+              <a:rPr sz="1297" b="0" i="1">
                 <a:solidFill>
                   <a:srgbClr val="64748B"/>
                 </a:solidFill>
@@ -8054,7 +8054,7 @@
               </a:spcAft>
             </a:pPr>
             <a:r>
-              <a:rPr sz="1200" b="1" i="0">
+              <a:rPr sz="1534" b="1" i="0">
                 <a:solidFill>
                   <a:srgbClr val="2563EB"/>
                 </a:solidFill>
@@ -8190,7 +8190,7 @@
               </a:spcAft>
             </a:pPr>
             <a:r>
-              <a:rPr sz="1200" b="0" i="0">
+              <a:rPr sz="1593" b="0" i="0">
                 <a:solidFill>
                   <a:srgbClr val="0F172A"/>
                 </a:solidFill>
@@ -8326,7 +8326,7 @@
               </a:spcAft>
             </a:pPr>
             <a:r>
-              <a:rPr sz="1200" b="0" i="0">
+              <a:rPr sz="1593" b="0" i="0">
                 <a:solidFill>
                   <a:srgbClr val="0F172A"/>
                 </a:solidFill>
@@ -8371,7 +8371,7 @@
               </a:spcAft>
             </a:pPr>
             <a:r>
-              <a:rPr sz="1250" b="0" i="0">
+              <a:rPr sz="1475" b="0" i="0">
                 <a:solidFill>
                   <a:srgbClr val="0F172A"/>
                 </a:solidFill>
@@ -8416,7 +8416,7 @@
               </a:spcAft>
             </a:pPr>
             <a:r>
-              <a:rPr sz="900" b="0" i="0">
+              <a:rPr sz="1238" b="0" i="0">
                 <a:solidFill>
                   <a:srgbClr val="64748B"/>
                 </a:solidFill>
@@ -8461,7 +8461,7 @@
               </a:spcAft>
             </a:pPr>
             <a:r>
-              <a:rPr sz="900" b="0" i="0">
+              <a:rPr sz="1238" b="0" i="0">
                 <a:solidFill>
                   <a:srgbClr val="64748B"/>
                 </a:solidFill>
@@ -8568,7 +8568,7 @@
               </a:spcAft>
             </a:pPr>
             <a:r>
-              <a:rPr sz="1250" b="1" i="0">
+              <a:rPr sz="1652" b="1" i="0">
                 <a:solidFill>
                   <a:srgbClr val="2563EB"/>
                 </a:solidFill>
@@ -8723,7 +8723,7 @@
         <p:spPr>
           <a:xfrm>
             <a:off x="713232" y="1892808"/>
-            <a:ext cx="3264408" cy="365760"/>
+            <a:ext cx="3264408" cy="548640"/>
           </a:xfrm>
           <a:prstGeom prst="rect">
             <a:avLst/>
@@ -8738,7 +8738,7 @@
           <a:p>
             <a:pPr algn="l">
               <a:lnSpc>
-                <a:spcPct val="100000"/>
+                <a:spcPct val="98000"/>
               </a:lnSpc>
               <a:spcBef>
                 <a:spcPts val="0"/>
@@ -8748,7 +8748,7 @@
               </a:spcAft>
             </a:pPr>
             <a:r>
-              <a:rPr sz="1500" b="1" i="0">
+              <a:rPr sz="1888" b="1" i="0">
                 <a:solidFill>
                   <a:srgbClr val="DC2626"/>
                 </a:solidFill>
@@ -8767,8 +8767,8 @@
         </p:nvSpPr>
         <p:spPr>
           <a:xfrm>
-            <a:off x="713232" y="2350008"/>
-            <a:ext cx="3264408" cy="3017520"/>
+            <a:off x="713232" y="2478024"/>
+            <a:ext cx="3264408" cy="2889504"/>
           </a:xfrm>
           <a:prstGeom prst="rect">
             <a:avLst/>
@@ -8793,7 +8793,7 @@
               </a:spcAft>
             </a:pPr>
             <a:r>
-              <a:rPr sz="1150" b="0">
+              <a:rPr sz="1534" b="0">
                 <a:solidFill>
                   <a:srgbClr val="DC2626"/>
                 </a:solidFill>
@@ -8802,7 +8802,7 @@
               <a:t>–  </a:t>
             </a:r>
             <a:r>
-              <a:rPr sz="1150">
+              <a:rPr sz="1534">
                 <a:solidFill>
                   <a:srgbClr val="0F172A"/>
                 </a:solidFill>
@@ -8824,7 +8824,7 @@
               </a:spcAft>
             </a:pPr>
             <a:r>
-              <a:rPr sz="1150" b="0">
+              <a:rPr sz="1534" b="0">
                 <a:solidFill>
                   <a:srgbClr val="DC2626"/>
                 </a:solidFill>
@@ -8833,7 +8833,7 @@
               <a:t>–  </a:t>
             </a:r>
             <a:r>
-              <a:rPr sz="1150">
+              <a:rPr sz="1534">
                 <a:solidFill>
                   <a:srgbClr val="0F172A"/>
                 </a:solidFill>
@@ -8855,7 +8855,7 @@
               </a:spcAft>
             </a:pPr>
             <a:r>
-              <a:rPr sz="1150" b="0">
+              <a:rPr sz="1534" b="0">
                 <a:solidFill>
                   <a:srgbClr val="DC2626"/>
                 </a:solidFill>
@@ -8864,7 +8864,7 @@
               <a:t>–  </a:t>
             </a:r>
             <a:r>
-              <a:rPr sz="1150">
+              <a:rPr sz="1534">
                 <a:solidFill>
                   <a:srgbClr val="0F172A"/>
                 </a:solidFill>
@@ -8886,7 +8886,7 @@
               </a:spcAft>
             </a:pPr>
             <a:r>
-              <a:rPr sz="1150" b="0">
+              <a:rPr sz="1534" b="0">
                 <a:solidFill>
                   <a:srgbClr val="DC2626"/>
                 </a:solidFill>
@@ -8895,7 +8895,7 @@
               <a:t>–  </a:t>
             </a:r>
             <a:r>
-              <a:rPr sz="1150">
+              <a:rPr sz="1534">
                 <a:solidFill>
                   <a:srgbClr val="0F172A"/>
                 </a:solidFill>
@@ -8917,7 +8917,7 @@
               </a:spcAft>
             </a:pPr>
             <a:r>
-              <a:rPr sz="1150" b="0">
+              <a:rPr sz="1534" b="0">
                 <a:solidFill>
                   <a:srgbClr val="DC2626"/>
                 </a:solidFill>
@@ -8926,7 +8926,7 @@
               <a:t>–  </a:t>
             </a:r>
             <a:r>
-              <a:rPr sz="1150">
+              <a:rPr sz="1534">
                 <a:solidFill>
                   <a:srgbClr val="0F172A"/>
                 </a:solidFill>
@@ -9036,7 +9036,7 @@
         <p:spPr>
           <a:xfrm>
             <a:off x="4443984" y="1892808"/>
-            <a:ext cx="3264408" cy="365760"/>
+            <a:ext cx="3264408" cy="548640"/>
           </a:xfrm>
           <a:prstGeom prst="rect">
             <a:avLst/>
@@ -9051,7 +9051,7 @@
           <a:p>
             <a:pPr algn="l">
               <a:lnSpc>
-                <a:spcPct val="100000"/>
+                <a:spcPct val="98000"/>
               </a:lnSpc>
               <a:spcBef>
                 <a:spcPts val="0"/>
@@ -9061,7 +9061,7 @@
               </a:spcAft>
             </a:pPr>
             <a:r>
-              <a:rPr sz="1500" b="1" i="0">
+              <a:rPr sz="1888" b="1" i="0">
                 <a:solidFill>
                   <a:srgbClr val="2563EB"/>
                 </a:solidFill>
@@ -9080,8 +9080,8 @@
         </p:nvSpPr>
         <p:spPr>
           <a:xfrm>
-            <a:off x="4443984" y="2350008"/>
-            <a:ext cx="3264408" cy="3017520"/>
+            <a:off x="4443984" y="2478024"/>
+            <a:ext cx="3264408" cy="2889504"/>
           </a:xfrm>
           <a:prstGeom prst="rect">
             <a:avLst/>
@@ -9106,7 +9106,7 @@
               </a:spcAft>
             </a:pPr>
             <a:r>
-              <a:rPr sz="1150" b="0">
+              <a:rPr sz="1534" b="0">
                 <a:solidFill>
                   <a:srgbClr val="2563EB"/>
                 </a:solidFill>
@@ -9115,7 +9115,7 @@
               <a:t>–  </a:t>
             </a:r>
             <a:r>
-              <a:rPr sz="1150">
+              <a:rPr sz="1534">
                 <a:solidFill>
                   <a:srgbClr val="0F172A"/>
                 </a:solidFill>
@@ -9137,7 +9137,7 @@
               </a:spcAft>
             </a:pPr>
             <a:r>
-              <a:rPr sz="1150" b="0">
+              <a:rPr sz="1534" b="0">
                 <a:solidFill>
                   <a:srgbClr val="2563EB"/>
                 </a:solidFill>
@@ -9146,7 +9146,7 @@
               <a:t>–  </a:t>
             </a:r>
             <a:r>
-              <a:rPr sz="1150">
+              <a:rPr sz="1534">
                 <a:solidFill>
                   <a:srgbClr val="0F172A"/>
                 </a:solidFill>
@@ -9168,7 +9168,7 @@
               </a:spcAft>
             </a:pPr>
             <a:r>
-              <a:rPr sz="1150" b="0">
+              <a:rPr sz="1534" b="0">
                 <a:solidFill>
                   <a:srgbClr val="2563EB"/>
                 </a:solidFill>
@@ -9177,7 +9177,7 @@
               <a:t>–  </a:t>
             </a:r>
             <a:r>
-              <a:rPr sz="1150">
+              <a:rPr sz="1534">
                 <a:solidFill>
                   <a:srgbClr val="0F172A"/>
                 </a:solidFill>
@@ -9199,7 +9199,7 @@
               </a:spcAft>
             </a:pPr>
             <a:r>
-              <a:rPr sz="1150" b="0">
+              <a:rPr sz="1534" b="0">
                 <a:solidFill>
                   <a:srgbClr val="2563EB"/>
                 </a:solidFill>
@@ -9208,7 +9208,7 @@
               <a:t>–  </a:t>
             </a:r>
             <a:r>
-              <a:rPr sz="1150">
+              <a:rPr sz="1534">
                 <a:solidFill>
                   <a:srgbClr val="0F172A"/>
                 </a:solidFill>
@@ -9230,7 +9230,7 @@
               </a:spcAft>
             </a:pPr>
             <a:r>
-              <a:rPr sz="1150" b="0">
+              <a:rPr sz="1534" b="0">
                 <a:solidFill>
                   <a:srgbClr val="2563EB"/>
                 </a:solidFill>
@@ -9239,7 +9239,7 @@
               <a:t>–  </a:t>
             </a:r>
             <a:r>
-              <a:rPr sz="1150">
+              <a:rPr sz="1534">
                 <a:solidFill>
                   <a:srgbClr val="0F172A"/>
                 </a:solidFill>
@@ -9349,7 +9349,7 @@
         <p:spPr>
           <a:xfrm>
             <a:off x="8174736" y="1892808"/>
-            <a:ext cx="3264408" cy="365760"/>
+            <a:ext cx="3264408" cy="548640"/>
           </a:xfrm>
           <a:prstGeom prst="rect">
             <a:avLst/>
@@ -9364,7 +9364,7 @@
           <a:p>
             <a:pPr algn="l">
               <a:lnSpc>
-                <a:spcPct val="100000"/>
+                <a:spcPct val="98000"/>
               </a:lnSpc>
               <a:spcBef>
                 <a:spcPts val="0"/>
@@ -9374,7 +9374,7 @@
               </a:spcAft>
             </a:pPr>
             <a:r>
-              <a:rPr sz="1500" b="1" i="0">
+              <a:rPr sz="1888" b="1" i="0">
                 <a:solidFill>
                   <a:srgbClr val="06B6D4"/>
                 </a:solidFill>
@@ -9393,8 +9393,8 @@
         </p:nvSpPr>
         <p:spPr>
           <a:xfrm>
-            <a:off x="8174736" y="2350008"/>
-            <a:ext cx="3264408" cy="3017520"/>
+            <a:off x="8174736" y="2478024"/>
+            <a:ext cx="3264408" cy="2889504"/>
           </a:xfrm>
           <a:prstGeom prst="rect">
             <a:avLst/>
@@ -9419,7 +9419,7 @@
               </a:spcAft>
             </a:pPr>
             <a:r>
-              <a:rPr sz="1150" b="0">
+              <a:rPr sz="1534" b="0">
                 <a:solidFill>
                   <a:srgbClr val="06B6D4"/>
                 </a:solidFill>
@@ -9428,7 +9428,7 @@
               <a:t>–  </a:t>
             </a:r>
             <a:r>
-              <a:rPr sz="1150">
+              <a:rPr sz="1534">
                 <a:solidFill>
                   <a:srgbClr val="0F172A"/>
                 </a:solidFill>
@@ -9450,7 +9450,7 @@
               </a:spcAft>
             </a:pPr>
             <a:r>
-              <a:rPr sz="1150" b="0">
+              <a:rPr sz="1534" b="0">
                 <a:solidFill>
                   <a:srgbClr val="06B6D4"/>
                 </a:solidFill>
@@ -9459,7 +9459,7 @@
               <a:t>–  </a:t>
             </a:r>
             <a:r>
-              <a:rPr sz="1150">
+              <a:rPr sz="1534">
                 <a:solidFill>
                   <a:srgbClr val="0F172A"/>
                 </a:solidFill>
@@ -9481,7 +9481,7 @@
               </a:spcAft>
             </a:pPr>
             <a:r>
-              <a:rPr sz="1150" b="0">
+              <a:rPr sz="1534" b="0">
                 <a:solidFill>
                   <a:srgbClr val="06B6D4"/>
                 </a:solidFill>
@@ -9490,7 +9490,7 @@
               <a:t>–  </a:t>
             </a:r>
             <a:r>
-              <a:rPr sz="1150">
+              <a:rPr sz="1534">
                 <a:solidFill>
                   <a:srgbClr val="0F172A"/>
                 </a:solidFill>
@@ -9512,7 +9512,7 @@
               </a:spcAft>
             </a:pPr>
             <a:r>
-              <a:rPr sz="1150" b="0">
+              <a:rPr sz="1534" b="0">
                 <a:solidFill>
                   <a:srgbClr val="06B6D4"/>
                 </a:solidFill>
@@ -9521,7 +9521,7 @@
               <a:t>–  </a:t>
             </a:r>
             <a:r>
-              <a:rPr sz="1150">
+              <a:rPr sz="1534">
                 <a:solidFill>
                   <a:srgbClr val="0F172A"/>
                 </a:solidFill>
@@ -9543,7 +9543,7 @@
               </a:spcAft>
             </a:pPr>
             <a:r>
-              <a:rPr sz="1150" b="0">
+              <a:rPr sz="1534" b="0">
                 <a:solidFill>
                   <a:srgbClr val="06B6D4"/>
                 </a:solidFill>
@@ -9552,7 +9552,7 @@
               <a:t>–  </a:t>
             </a:r>
             <a:r>
-              <a:rPr sz="1150">
+              <a:rPr sz="1534">
                 <a:solidFill>
                   <a:srgbClr val="0F172A"/>
                 </a:solidFill>
@@ -9597,7 +9597,7 @@
               </a:spcAft>
             </a:pPr>
             <a:r>
-              <a:rPr sz="950" b="0" i="1">
+              <a:rPr sz="1297" b="0" i="1">
                 <a:solidFill>
                   <a:srgbClr val="64748B"/>
                 </a:solidFill>
@@ -9642,7 +9642,7 @@
               </a:spcAft>
             </a:pPr>
             <a:r>
-              <a:rPr sz="900" b="0" i="0">
+              <a:rPr sz="1238" b="0" i="0">
                 <a:solidFill>
                   <a:srgbClr val="64748B"/>
                 </a:solidFill>
@@ -9687,7 +9687,7 @@
               </a:spcAft>
             </a:pPr>
             <a:r>
-              <a:rPr sz="900" b="0" i="0">
+              <a:rPr sz="1238" b="0" i="0">
                 <a:solidFill>
                   <a:srgbClr val="64748B"/>
                 </a:solidFill>
@@ -9794,7 +9794,7 @@
               </a:spcAft>
             </a:pPr>
             <a:r>
-              <a:rPr sz="1250" b="1" i="0">
+              <a:rPr sz="1652" b="1" i="0">
                 <a:solidFill>
                   <a:srgbClr val="2563EB"/>
                 </a:solidFill>
@@ -9972,7 +9972,7 @@
               </a:spcAft>
             </a:pPr>
             <a:r>
-              <a:rPr sz="1150" b="1" i="0">
+              <a:rPr sz="1534" b="1" i="0">
                 <a:solidFill>
                   <a:srgbClr val="FFFFFF"/>
                 </a:solidFill>
@@ -10061,7 +10061,7 @@
               </a:spcAft>
             </a:pPr>
             <a:r>
-              <a:rPr sz="1150" b="1" i="0">
+              <a:rPr sz="1534" b="1" i="0">
                 <a:solidFill>
                   <a:srgbClr val="FFFFFF"/>
                 </a:solidFill>
@@ -10150,7 +10150,7 @@
               </a:spcAft>
             </a:pPr>
             <a:r>
-              <a:rPr sz="1150" b="1" i="0">
+              <a:rPr sz="1534" b="1" i="0">
                 <a:solidFill>
                   <a:srgbClr val="FFFFFF"/>
                 </a:solidFill>
@@ -10239,7 +10239,7 @@
               </a:spcAft>
             </a:pPr>
             <a:r>
-              <a:rPr sz="1150" b="1" i="0">
+              <a:rPr sz="1534" b="1" i="0">
                 <a:solidFill>
                   <a:srgbClr val="FFFFFF"/>
                 </a:solidFill>
@@ -10328,7 +10328,7 @@
               </a:spcAft>
             </a:pPr>
             <a:r>
-              <a:rPr sz="1150" b="1" i="0">
+              <a:rPr sz="1534" b="1" i="0">
                 <a:solidFill>
                   <a:srgbClr val="FFFFFF"/>
                 </a:solidFill>
@@ -10417,7 +10417,7 @@
               </a:spcAft>
             </a:pPr>
             <a:r>
-              <a:rPr sz="1600" b="1" i="0">
+              <a:rPr sz="1888" b="1" i="0">
                 <a:solidFill>
                   <a:srgbClr val="FFFFFF"/>
                 </a:solidFill>
@@ -10552,7 +10552,7 @@
               </a:spcAft>
             </a:pPr>
             <a:r>
-              <a:rPr sz="1050" b="1" i="0">
+              <a:rPr sz="1416" b="1" i="0">
                 <a:solidFill>
                   <a:srgbClr val="DC2626"/>
                 </a:solidFill>
@@ -10687,7 +10687,7 @@
               </a:spcAft>
             </a:pPr>
             <a:r>
-              <a:rPr sz="1050" b="1" i="0">
+              <a:rPr sz="1416" b="1" i="0">
                 <a:solidFill>
                   <a:srgbClr val="DC2626"/>
                 </a:solidFill>
@@ -10822,7 +10822,7 @@
               </a:spcAft>
             </a:pPr>
             <a:r>
-              <a:rPr sz="1050" b="1" i="0">
+              <a:rPr sz="1416" b="1" i="0">
                 <a:solidFill>
                   <a:srgbClr val="D97706"/>
                 </a:solidFill>
@@ -10957,7 +10957,7 @@
               </a:spcAft>
             </a:pPr>
             <a:r>
-              <a:rPr sz="1050" b="1" i="0">
+              <a:rPr sz="1416" b="1" i="0">
                 <a:solidFill>
                   <a:srgbClr val="DC2626"/>
                 </a:solidFill>
@@ -11092,7 +11092,7 @@
               </a:spcAft>
             </a:pPr>
             <a:r>
-              <a:rPr sz="1050" b="1" i="0">
+              <a:rPr sz="1416" b="1" i="0">
                 <a:solidFill>
                   <a:srgbClr val="DC2626"/>
                 </a:solidFill>
@@ -11181,7 +11181,7 @@
               </a:spcAft>
             </a:pPr>
             <a:r>
-              <a:rPr sz="1600" b="1" i="0">
+              <a:rPr sz="1888" b="1" i="0">
                 <a:solidFill>
                   <a:srgbClr val="FFFFFF"/>
                 </a:solidFill>
@@ -11316,7 +11316,7 @@
               </a:spcAft>
             </a:pPr>
             <a:r>
-              <a:rPr sz="1050" b="1" i="0">
+              <a:rPr sz="1416" b="1" i="0">
                 <a:solidFill>
                   <a:srgbClr val="16A34A"/>
                 </a:solidFill>
@@ -11451,7 +11451,7 @@
               </a:spcAft>
             </a:pPr>
             <a:r>
-              <a:rPr sz="1050" b="1" i="0">
+              <a:rPr sz="1416" b="1" i="0">
                 <a:solidFill>
                   <a:srgbClr val="D97706"/>
                 </a:solidFill>
@@ -11586,7 +11586,7 @@
               </a:spcAft>
             </a:pPr>
             <a:r>
-              <a:rPr sz="1050" b="1" i="0">
+              <a:rPr sz="1416" b="1" i="0">
                 <a:solidFill>
                   <a:srgbClr val="16A34A"/>
                 </a:solidFill>
@@ -11721,7 +11721,7 @@
               </a:spcAft>
             </a:pPr>
             <a:r>
-              <a:rPr sz="1050" b="1" i="0">
+              <a:rPr sz="1416" b="1" i="0">
                 <a:solidFill>
                   <a:srgbClr val="16A34A"/>
                 </a:solidFill>
@@ -11856,7 +11856,7 @@
               </a:spcAft>
             </a:pPr>
             <a:r>
-              <a:rPr sz="1050" b="1" i="0">
+              <a:rPr sz="1416" b="1" i="0">
                 <a:solidFill>
                   <a:srgbClr val="16A34A"/>
                 </a:solidFill>
@@ -11945,7 +11945,7 @@
               </a:spcAft>
             </a:pPr>
             <a:r>
-              <a:rPr sz="1600" b="1" i="0">
+              <a:rPr sz="1888" b="1" i="0">
                 <a:solidFill>
                   <a:srgbClr val="FFFFFF"/>
                 </a:solidFill>
@@ -12080,7 +12080,7 @@
               </a:spcAft>
             </a:pPr>
             <a:r>
-              <a:rPr sz="1050" b="1" i="0">
+              <a:rPr sz="1416" b="1" i="0">
                 <a:solidFill>
                   <a:srgbClr val="16A34A"/>
                 </a:solidFill>
@@ -12215,7 +12215,7 @@
               </a:spcAft>
             </a:pPr>
             <a:r>
-              <a:rPr sz="1050" b="1" i="0">
+              <a:rPr sz="1416" b="1" i="0">
                 <a:solidFill>
                   <a:srgbClr val="D97706"/>
                 </a:solidFill>
@@ -12350,7 +12350,7 @@
               </a:spcAft>
             </a:pPr>
             <a:r>
-              <a:rPr sz="1050" b="1" i="0">
+              <a:rPr sz="1416" b="1" i="0">
                 <a:solidFill>
                   <a:srgbClr val="D97706"/>
                 </a:solidFill>
@@ -12485,7 +12485,7 @@
               </a:spcAft>
             </a:pPr>
             <a:r>
-              <a:rPr sz="1050" b="1" i="0">
+              <a:rPr sz="1416" b="1" i="0">
                 <a:solidFill>
                   <a:srgbClr val="D97706"/>
                 </a:solidFill>
@@ -12620,7 +12620,7 @@
               </a:spcAft>
             </a:pPr>
             <a:r>
-              <a:rPr sz="1050" b="1" i="0">
+              <a:rPr sz="1416" b="1" i="0">
                 <a:solidFill>
                   <a:srgbClr val="D97706"/>
                 </a:solidFill>
@@ -12665,7 +12665,7 @@
               </a:spcAft>
             </a:pPr>
             <a:r>
-              <a:rPr sz="1350" b="1" i="0">
+              <a:rPr sz="1593" b="1" i="0">
                 <a:solidFill>
                   <a:srgbClr val="0F172A"/>
                 </a:solidFill>
@@ -12754,7 +12754,7 @@
               </a:spcAft>
             </a:pPr>
             <a:r>
-              <a:rPr sz="1000" b="0" i="0">
+              <a:rPr sz="1297" b="0" i="0">
                 <a:solidFill>
                   <a:srgbClr val="64748B"/>
                 </a:solidFill>
@@ -12843,7 +12843,7 @@
               </a:spcAft>
             </a:pPr>
             <a:r>
-              <a:rPr sz="1000" b="0" i="0">
+              <a:rPr sz="1297" b="0" i="0">
                 <a:solidFill>
                   <a:srgbClr val="64748B"/>
                 </a:solidFill>
@@ -12932,7 +12932,7 @@
               </a:spcAft>
             </a:pPr>
             <a:r>
-              <a:rPr sz="1000" b="0" i="0">
+              <a:rPr sz="1297" b="0" i="0">
                 <a:solidFill>
                   <a:srgbClr val="64748B"/>
                 </a:solidFill>
@@ -12977,7 +12977,7 @@
               </a:spcAft>
             </a:pPr>
             <a:r>
-              <a:rPr sz="900" b="0" i="0">
+              <a:rPr sz="1238" b="0" i="0">
                 <a:solidFill>
                   <a:srgbClr val="64748B"/>
                 </a:solidFill>
@@ -13022,7 +13022,7 @@
               </a:spcAft>
             </a:pPr>
             <a:r>
-              <a:rPr sz="900" b="0" i="0">
+              <a:rPr sz="1238" b="0" i="0">
                 <a:solidFill>
                   <a:srgbClr val="64748B"/>
                 </a:solidFill>
@@ -13129,7 +13129,7 @@
               </a:spcAft>
             </a:pPr>
             <a:r>
-              <a:rPr sz="1250" b="1" i="0">
+              <a:rPr sz="1652" b="1" i="0">
                 <a:solidFill>
                   <a:srgbClr val="2563EB"/>
                 </a:solidFill>
@@ -13309,7 +13309,7 @@
               </a:spcAft>
             </a:pPr>
             <a:r>
-              <a:rPr sz="1200" b="1" i="0">
+              <a:rPr sz="1534" b="1" i="0">
                 <a:solidFill>
                   <a:srgbClr val="2563EB"/>
                 </a:solidFill>
@@ -13354,7 +13354,7 @@
               </a:spcAft>
             </a:pPr>
             <a:r>
-              <a:rPr sz="1600" b="1" i="0">
+              <a:rPr sz="1888" b="1" i="0">
                 <a:solidFill>
                   <a:srgbClr val="0F172A"/>
                 </a:solidFill>
@@ -13399,7 +13399,7 @@
               </a:spcAft>
             </a:pPr>
             <a:r>
-              <a:rPr sz="1300" b="0">
+              <a:rPr sz="1534" b="0">
                 <a:solidFill>
                   <a:srgbClr val="2563EB"/>
                 </a:solidFill>
@@ -13408,7 +13408,7 @@
               <a:t>–  </a:t>
             </a:r>
             <a:r>
-              <a:rPr sz="1300">
+              <a:rPr sz="1534">
                 <a:solidFill>
                   <a:srgbClr val="0F172A"/>
                 </a:solidFill>
@@ -13430,7 +13430,7 @@
               </a:spcAft>
             </a:pPr>
             <a:r>
-              <a:rPr sz="1300" b="0">
+              <a:rPr sz="1534" b="0">
                 <a:solidFill>
                   <a:srgbClr val="2563EB"/>
                 </a:solidFill>
@@ -13439,7 +13439,7 @@
               <a:t>–  </a:t>
             </a:r>
             <a:r>
-              <a:rPr sz="1300">
+              <a:rPr sz="1534">
                 <a:solidFill>
                   <a:srgbClr val="0F172A"/>
                 </a:solidFill>
@@ -13461,7 +13461,7 @@
               </a:spcAft>
             </a:pPr>
             <a:r>
-              <a:rPr sz="1300" b="0">
+              <a:rPr sz="1534" b="0">
                 <a:solidFill>
                   <a:srgbClr val="2563EB"/>
                 </a:solidFill>
@@ -13470,7 +13470,7 @@
               <a:t>–  </a:t>
             </a:r>
             <a:r>
-              <a:rPr sz="1300">
+              <a:rPr sz="1534">
                 <a:solidFill>
                   <a:srgbClr val="0F172A"/>
                 </a:solidFill>
@@ -13605,7 +13605,7 @@
               </a:spcAft>
             </a:pPr>
             <a:r>
-              <a:rPr sz="1200" b="1" i="0">
+              <a:rPr sz="1534" b="1" i="0">
                 <a:solidFill>
                   <a:srgbClr val="DC2626"/>
                 </a:solidFill>
@@ -13650,7 +13650,7 @@
               </a:spcAft>
             </a:pPr>
             <a:r>
-              <a:rPr sz="1600" b="1" i="0">
+              <a:rPr sz="1888" b="1" i="0">
                 <a:solidFill>
                   <a:srgbClr val="0F172A"/>
                 </a:solidFill>
@@ -13695,7 +13695,7 @@
               </a:spcAft>
             </a:pPr>
             <a:r>
-              <a:rPr sz="1300" b="0">
+              <a:rPr sz="1534" b="0">
                 <a:solidFill>
                   <a:srgbClr val="2563EB"/>
                 </a:solidFill>
@@ -13704,7 +13704,7 @@
               <a:t>–  </a:t>
             </a:r>
             <a:r>
-              <a:rPr sz="1300">
+              <a:rPr sz="1534">
                 <a:solidFill>
                   <a:srgbClr val="0F172A"/>
                 </a:solidFill>
@@ -13726,7 +13726,7 @@
               </a:spcAft>
             </a:pPr>
             <a:r>
-              <a:rPr sz="1300" b="0">
+              <a:rPr sz="1534" b="0">
                 <a:solidFill>
                   <a:srgbClr val="2563EB"/>
                 </a:solidFill>
@@ -13735,7 +13735,7 @@
               <a:t>–  </a:t>
             </a:r>
             <a:r>
-              <a:rPr sz="1300">
+              <a:rPr sz="1534">
                 <a:solidFill>
                   <a:srgbClr val="0F172A"/>
                 </a:solidFill>
@@ -13824,7 +13824,7 @@
               </a:spcAft>
             </a:pPr>
             <a:r>
-              <a:rPr sz="1200" b="1" i="0">
+              <a:rPr sz="1534" b="1" i="0">
                 <a:solidFill>
                   <a:srgbClr val="DC2626"/>
                 </a:solidFill>
@@ -13846,7 +13846,7 @@
               </a:spcAft>
             </a:pPr>
             <a:r>
-              <a:rPr sz="1200" b="1" i="0">
+              <a:rPr sz="1534" b="1" i="0">
                 <a:solidFill>
                   <a:srgbClr val="DC2626"/>
                 </a:solidFill>
@@ -13935,7 +13935,7 @@
               </a:spcAft>
             </a:pPr>
             <a:r>
-              <a:rPr sz="1200" b="1" i="0">
+              <a:rPr sz="1534" b="1" i="0">
                 <a:solidFill>
                   <a:srgbClr val="2563EB"/>
                 </a:solidFill>
@@ -13957,7 +13957,7 @@
               </a:spcAft>
             </a:pPr>
             <a:r>
-              <a:rPr sz="1200" b="1" i="0">
+              <a:rPr sz="1534" b="1" i="0">
                 <a:solidFill>
                   <a:srgbClr val="2563EB"/>
                 </a:solidFill>
@@ -14002,7 +14002,7 @@
               </a:spcAft>
             </a:pPr>
             <a:r>
-              <a:rPr sz="900" b="0" i="0">
+              <a:rPr sz="1238" b="0" i="0">
                 <a:solidFill>
                   <a:srgbClr val="64748B"/>
                 </a:solidFill>
@@ -14047,7 +14047,7 @@
               </a:spcAft>
             </a:pPr>
             <a:r>
-              <a:rPr sz="900" b="0" i="0">
+              <a:rPr sz="1238" b="0" i="0">
                 <a:solidFill>
                   <a:srgbClr val="64748B"/>
                 </a:solidFill>
@@ -14198,7 +14198,7 @@
               </a:spcAft>
             </a:pPr>
             <a:r>
-              <a:rPr sz="1250" b="1" i="0">
+              <a:rPr sz="1534" b="1" i="0">
                 <a:solidFill>
                   <a:srgbClr val="06B6D4"/>
                 </a:solidFill>
@@ -14288,7 +14288,7 @@
               </a:spcAft>
             </a:pPr>
             <a:r>
-              <a:rPr sz="1200" b="1" i="0">
+              <a:rPr sz="1534" b="1" i="0">
                 <a:solidFill>
                   <a:srgbClr val="06B6D4"/>
                 </a:solidFill>
@@ -14333,7 +14333,7 @@
               </a:spcAft>
             </a:pPr>
             <a:r>
-              <a:rPr sz="1600" b="1" i="0">
+              <a:rPr sz="1888" b="1" i="0">
                 <a:solidFill>
                   <a:srgbClr val="FFFFFF"/>
                 </a:solidFill>
@@ -14378,7 +14378,7 @@
               </a:spcAft>
             </a:pPr>
             <a:r>
-              <a:rPr sz="1350" b="0">
+              <a:rPr sz="1593" b="0">
                 <a:solidFill>
                   <a:srgbClr val="06B6D4"/>
                 </a:solidFill>
@@ -14387,7 +14387,7 @@
               <a:t>–  </a:t>
             </a:r>
             <a:r>
-              <a:rPr sz="1350">
+              <a:rPr sz="1593">
                 <a:solidFill>
                   <a:srgbClr val="E2E8F0"/>
                 </a:solidFill>
@@ -14409,7 +14409,7 @@
               </a:spcAft>
             </a:pPr>
             <a:r>
-              <a:rPr sz="1350" b="0">
+              <a:rPr sz="1593" b="0">
                 <a:solidFill>
                   <a:srgbClr val="06B6D4"/>
                 </a:solidFill>
@@ -14418,7 +14418,7 @@
               <a:t>–  </a:t>
             </a:r>
             <a:r>
-              <a:rPr sz="1350">
+              <a:rPr sz="1593">
                 <a:solidFill>
                   <a:srgbClr val="E2E8F0"/>
                 </a:solidFill>
@@ -14440,7 +14440,7 @@
               </a:spcAft>
             </a:pPr>
             <a:r>
-              <a:rPr sz="1350" b="0">
+              <a:rPr sz="1593" b="0">
                 <a:solidFill>
                   <a:srgbClr val="06B6D4"/>
                 </a:solidFill>
@@ -14449,7 +14449,7 @@
               <a:t>–  </a:t>
             </a:r>
             <a:r>
-              <a:rPr sz="1350">
+              <a:rPr sz="1593">
                 <a:solidFill>
                   <a:srgbClr val="E2E8F0"/>
                 </a:solidFill>
@@ -14538,7 +14538,7 @@
               </a:spcAft>
             </a:pPr>
             <a:r>
-              <a:rPr sz="1350" b="1" i="0">
+              <a:rPr sz="1593" b="1" i="0">
                 <a:solidFill>
                   <a:srgbClr val="FFFFFF"/>
                 </a:solidFill>
@@ -14560,7 +14560,7 @@
               </a:spcAft>
             </a:pPr>
             <a:r>
-              <a:rPr sz="1350" b="0" i="0">
+              <a:rPr sz="1593" b="0" i="0">
                 <a:solidFill>
                   <a:srgbClr val="E2E8F0"/>
                 </a:solidFill>
@@ -14738,7 +14738,7 @@
               </a:spcAft>
             </a:pPr>
             <a:r>
-              <a:rPr sz="1800" b="1" i="1">
+              <a:rPr sz="2124" b="1" i="1">
                 <a:solidFill>
                   <a:srgbClr val="FFFFFF"/>
                 </a:solidFill>
@@ -14783,7 +14783,7 @@
               </a:spcAft>
             </a:pPr>
             <a:r>
-              <a:rPr sz="900" b="0" i="0">
+              <a:rPr sz="1238" b="0" i="0">
                 <a:solidFill>
                   <a:srgbClr val="64748B"/>
                 </a:solidFill>
@@ -14828,7 +14828,7 @@
               </a:spcAft>
             </a:pPr>
             <a:r>
-              <a:rPr sz="900" b="0" i="0">
+              <a:rPr sz="1238" b="0" i="0">
                 <a:solidFill>
                   <a:srgbClr val="64748B"/>
                 </a:solidFill>
@@ -14935,7 +14935,7 @@
               </a:spcAft>
             </a:pPr>
             <a:r>
-              <a:rPr sz="1250" b="1" i="0">
+              <a:rPr sz="1652" b="1" i="0">
                 <a:solidFill>
                   <a:srgbClr val="2563EB"/>
                 </a:solidFill>
@@ -15115,7 +15115,7 @@
               </a:spcAft>
             </a:pPr>
             <a:r>
-              <a:rPr sz="1600" b="1" i="0">
+              <a:rPr sz="1888" b="1" i="0">
                 <a:solidFill>
                   <a:srgbClr val="D97706"/>
                 </a:solidFill>
@@ -15160,7 +15160,7 @@
               </a:spcAft>
             </a:pPr>
             <a:r>
-              <a:rPr sz="1300" b="0">
+              <a:rPr sz="1534" b="0">
                 <a:solidFill>
                   <a:srgbClr val="D97706"/>
                 </a:solidFill>
@@ -15169,7 +15169,7 @@
               <a:t>–  </a:t>
             </a:r>
             <a:r>
-              <a:rPr sz="1300">
+              <a:rPr sz="1534">
                 <a:solidFill>
                   <a:srgbClr val="0F172A"/>
                 </a:solidFill>
@@ -15191,7 +15191,7 @@
               </a:spcAft>
             </a:pPr>
             <a:r>
-              <a:rPr sz="1300" b="0">
+              <a:rPr sz="1534" b="0">
                 <a:solidFill>
                   <a:srgbClr val="D97706"/>
                 </a:solidFill>
@@ -15200,7 +15200,7 @@
               <a:t>–  </a:t>
             </a:r>
             <a:r>
-              <a:rPr sz="1300">
+              <a:rPr sz="1534">
                 <a:solidFill>
                   <a:srgbClr val="0F172A"/>
                 </a:solidFill>
@@ -15222,7 +15222,7 @@
               </a:spcAft>
             </a:pPr>
             <a:r>
-              <a:rPr sz="1300" b="0">
+              <a:rPr sz="1534" b="0">
                 <a:solidFill>
                   <a:srgbClr val="D97706"/>
                 </a:solidFill>
@@ -15231,7 +15231,7 @@
               <a:t>–  </a:t>
             </a:r>
             <a:r>
-              <a:rPr sz="1300">
+              <a:rPr sz="1534">
                 <a:solidFill>
                   <a:srgbClr val="0F172A"/>
                 </a:solidFill>
@@ -15253,7 +15253,7 @@
               </a:spcAft>
             </a:pPr>
             <a:r>
-              <a:rPr sz="1300" b="0">
+              <a:rPr sz="1534" b="0">
                 <a:solidFill>
                   <a:srgbClr val="D97706"/>
                 </a:solidFill>
@@ -15262,7 +15262,7 @@
               <a:t>–  </a:t>
             </a:r>
             <a:r>
-              <a:rPr sz="1300">
+              <a:rPr sz="1534">
                 <a:solidFill>
                   <a:srgbClr val="0F172A"/>
                 </a:solidFill>
@@ -15397,7 +15397,7 @@
               </a:spcAft>
             </a:pPr>
             <a:r>
-              <a:rPr sz="1600" b="1" i="0">
+              <a:rPr sz="1888" b="1" i="0">
                 <a:solidFill>
                   <a:srgbClr val="2563EB"/>
                 </a:solidFill>
@@ -15442,7 +15442,7 @@
               </a:spcAft>
             </a:pPr>
             <a:r>
-              <a:rPr sz="1300" b="0">
+              <a:rPr sz="1534" b="0">
                 <a:solidFill>
                   <a:srgbClr val="2563EB"/>
                 </a:solidFill>
@@ -15451,7 +15451,7 @@
               <a:t>–  </a:t>
             </a:r>
             <a:r>
-              <a:rPr sz="1300">
+              <a:rPr sz="1534">
                 <a:solidFill>
                   <a:srgbClr val="0F172A"/>
                 </a:solidFill>
@@ -15473,7 +15473,7 @@
               </a:spcAft>
             </a:pPr>
             <a:r>
-              <a:rPr sz="1300" b="0">
+              <a:rPr sz="1534" b="0">
                 <a:solidFill>
                   <a:srgbClr val="2563EB"/>
                 </a:solidFill>
@@ -15482,7 +15482,7 @@
               <a:t>–  </a:t>
             </a:r>
             <a:r>
-              <a:rPr sz="1300">
+              <a:rPr sz="1534">
                 <a:solidFill>
                   <a:srgbClr val="0F172A"/>
                 </a:solidFill>
@@ -15504,7 +15504,7 @@
               </a:spcAft>
             </a:pPr>
             <a:r>
-              <a:rPr sz="1300" b="0">
+              <a:rPr sz="1534" b="0">
                 <a:solidFill>
                   <a:srgbClr val="2563EB"/>
                 </a:solidFill>
@@ -15513,7 +15513,7 @@
               <a:t>–  </a:t>
             </a:r>
             <a:r>
-              <a:rPr sz="1300">
+              <a:rPr sz="1534">
                 <a:solidFill>
                   <a:srgbClr val="0F172A"/>
                 </a:solidFill>
@@ -15535,7 +15535,7 @@
               </a:spcAft>
             </a:pPr>
             <a:r>
-              <a:rPr sz="1300" b="0">
+              <a:rPr sz="1534" b="0">
                 <a:solidFill>
                   <a:srgbClr val="2563EB"/>
                 </a:solidFill>
@@ -15544,7 +15544,7 @@
               <a:t>–  </a:t>
             </a:r>
             <a:r>
-              <a:rPr sz="1300">
+              <a:rPr sz="1534">
                 <a:solidFill>
                   <a:srgbClr val="0F172A"/>
                 </a:solidFill>
@@ -15589,7 +15589,7 @@
               </a:spcAft>
             </a:pPr>
             <a:r>
-              <a:rPr sz="900" b="0" i="0">
+              <a:rPr sz="1238" b="0" i="0">
                 <a:solidFill>
                   <a:srgbClr val="64748B"/>
                 </a:solidFill>
@@ -15634,7 +15634,7 @@
               </a:spcAft>
             </a:pPr>
             <a:r>
-              <a:rPr sz="900" b="0" i="0">
+              <a:rPr sz="1238" b="0" i="0">
                 <a:solidFill>
                   <a:srgbClr val="64748B"/>
                 </a:solidFill>
@@ -15741,7 +15741,7 @@
               </a:spcAft>
             </a:pPr>
             <a:r>
-              <a:rPr sz="1250" b="1" i="0">
+              <a:rPr sz="1652" b="1" i="0">
                 <a:solidFill>
                   <a:srgbClr val="2563EB"/>
                 </a:solidFill>
@@ -15831,7 +15831,7 @@
               </a:spcAft>
             </a:pPr>
             <a:r>
-              <a:rPr sz="1200" b="1" i="0">
+              <a:rPr sz="1534" b="1" i="0">
                 <a:solidFill>
                   <a:srgbClr val="2563EB"/>
                 </a:solidFill>
@@ -15966,7 +15966,7 @@
               </a:spcAft>
             </a:pPr>
             <a:r>
-              <a:rPr sz="1400" b="1" i="0">
+              <a:rPr sz="1652" b="1" i="0">
                 <a:solidFill>
                   <a:srgbClr val="0F172A"/>
                 </a:solidFill>
@@ -16011,7 +16011,7 @@
               </a:spcAft>
             </a:pPr>
             <a:r>
-              <a:rPr sz="1200" b="0" i="0">
+              <a:rPr sz="1593" b="0" i="0">
                 <a:solidFill>
                   <a:srgbClr val="0F172A"/>
                 </a:solidFill>
@@ -16146,7 +16146,7 @@
               </a:spcAft>
             </a:pPr>
             <a:r>
-              <a:rPr sz="1400" b="1" i="0">
+              <a:rPr sz="1652" b="1" i="0">
                 <a:solidFill>
                   <a:srgbClr val="0F172A"/>
                 </a:solidFill>
@@ -16191,7 +16191,7 @@
               </a:spcAft>
             </a:pPr>
             <a:r>
-              <a:rPr sz="1200" b="0" i="0">
+              <a:rPr sz="1593" b="0" i="0">
                 <a:solidFill>
                   <a:srgbClr val="0F172A"/>
                 </a:solidFill>
@@ -16236,7 +16236,7 @@
               </a:spcAft>
             </a:pPr>
             <a:r>
-              <a:rPr sz="1200" b="1" i="0">
+              <a:rPr sz="1534" b="1" i="0">
                 <a:solidFill>
                   <a:srgbClr val="2563EB"/>
                 </a:solidFill>
@@ -16371,7 +16371,7 @@
               </a:spcAft>
             </a:pPr>
             <a:r>
-              <a:rPr sz="1250" b="1" i="0">
+              <a:rPr sz="1593" b="1" i="0">
                 <a:solidFill>
                   <a:srgbClr val="06B6D4"/>
                 </a:solidFill>
@@ -16416,7 +16416,7 @@
               </a:spcAft>
             </a:pPr>
             <a:r>
-              <a:rPr sz="1150" b="0" i="0">
+              <a:rPr sz="1534" b="0" i="0">
                 <a:solidFill>
                   <a:srgbClr val="0F172A"/>
                 </a:solidFill>
@@ -16438,7 +16438,7 @@
               </a:spcAft>
             </a:pPr>
             <a:r>
-              <a:rPr sz="1150" b="0" i="0">
+              <a:rPr sz="1534" b="0" i="0">
                 <a:solidFill>
                   <a:srgbClr val="0F172A"/>
                 </a:solidFill>
@@ -16573,7 +16573,7 @@
               </a:spcAft>
             </a:pPr>
             <a:r>
-              <a:rPr sz="1250" b="1" i="0">
+              <a:rPr sz="1593" b="1" i="0">
                 <a:solidFill>
                   <a:srgbClr val="06B6D4"/>
                 </a:solidFill>
@@ -16618,7 +16618,7 @@
               </a:spcAft>
             </a:pPr>
             <a:r>
-              <a:rPr sz="1150" b="0" i="0">
+              <a:rPr sz="1534" b="0" i="0">
                 <a:solidFill>
                   <a:srgbClr val="0F172A"/>
                 </a:solidFill>
@@ -16640,7 +16640,7 @@
               </a:spcAft>
             </a:pPr>
             <a:r>
-              <a:rPr sz="1150" b="0" i="0">
+              <a:rPr sz="1534" b="0" i="0">
                 <a:solidFill>
                   <a:srgbClr val="0F172A"/>
                 </a:solidFill>
@@ -16775,7 +16775,7 @@
               </a:spcAft>
             </a:pPr>
             <a:r>
-              <a:rPr sz="1250" b="1" i="0">
+              <a:rPr sz="1593" b="1" i="0">
                 <a:solidFill>
                   <a:srgbClr val="06B6D4"/>
                 </a:solidFill>
@@ -16820,7 +16820,7 @@
               </a:spcAft>
             </a:pPr>
             <a:r>
-              <a:rPr sz="1150" b="0" i="0">
+              <a:rPr sz="1534" b="0" i="0">
                 <a:solidFill>
                   <a:srgbClr val="0F172A"/>
                 </a:solidFill>
@@ -16842,7 +16842,7 @@
               </a:spcAft>
             </a:pPr>
             <a:r>
-              <a:rPr sz="1150" b="0" i="0">
+              <a:rPr sz="1534" b="0" i="0">
                 <a:solidFill>
                   <a:srgbClr val="0F172A"/>
                 </a:solidFill>
@@ -16977,7 +16977,7 @@
               </a:spcAft>
             </a:pPr>
             <a:r>
-              <a:rPr sz="1250" b="1" i="0">
+              <a:rPr sz="1593" b="1" i="0">
                 <a:solidFill>
                   <a:srgbClr val="06B6D4"/>
                 </a:solidFill>
@@ -17022,7 +17022,7 @@
               </a:spcAft>
             </a:pPr>
             <a:r>
-              <a:rPr sz="1150" b="0" i="0">
+              <a:rPr sz="1534" b="0" i="0">
                 <a:solidFill>
                   <a:srgbClr val="0F172A"/>
                 </a:solidFill>
@@ -17044,7 +17044,7 @@
               </a:spcAft>
             </a:pPr>
             <a:r>
-              <a:rPr sz="1150" b="0" i="0">
+              <a:rPr sz="1534" b="0" i="0">
                 <a:solidFill>
                   <a:srgbClr val="0F172A"/>
                 </a:solidFill>
@@ -17179,7 +17179,7 @@
               </a:spcAft>
             </a:pPr>
             <a:r>
-              <a:rPr sz="1250" b="1" i="0">
+              <a:rPr sz="1593" b="1" i="0">
                 <a:solidFill>
                   <a:srgbClr val="06B6D4"/>
                 </a:solidFill>
@@ -17224,7 +17224,7 @@
               </a:spcAft>
             </a:pPr>
             <a:r>
-              <a:rPr sz="1150" b="0" i="0">
+              <a:rPr sz="1534" b="0" i="0">
                 <a:solidFill>
                   <a:srgbClr val="0F172A"/>
                 </a:solidFill>
@@ -17246,7 +17246,7 @@
               </a:spcAft>
             </a:pPr>
             <a:r>
-              <a:rPr sz="1150" b="0" i="0">
+              <a:rPr sz="1534" b="0" i="0">
                 <a:solidFill>
                   <a:srgbClr val="0F172A"/>
                 </a:solidFill>
@@ -17291,7 +17291,7 @@
               </a:spcAft>
             </a:pPr>
             <a:r>
-              <a:rPr sz="1300" b="0">
+              <a:rPr sz="1534" b="0">
                 <a:solidFill>
                   <a:srgbClr val="2563EB"/>
                 </a:solidFill>
@@ -17300,7 +17300,7 @@
               <a:t>–  </a:t>
             </a:r>
             <a:r>
-              <a:rPr sz="1300">
+              <a:rPr sz="1534">
                 <a:solidFill>
                   <a:srgbClr val="0F172A"/>
                 </a:solidFill>
@@ -17322,7 +17322,7 @@
               </a:spcAft>
             </a:pPr>
             <a:r>
-              <a:rPr sz="1300" b="0">
+              <a:rPr sz="1534" b="0">
                 <a:solidFill>
                   <a:srgbClr val="2563EB"/>
                 </a:solidFill>
@@ -17331,7 +17331,7 @@
               <a:t>–  </a:t>
             </a:r>
             <a:r>
-              <a:rPr sz="1300">
+              <a:rPr sz="1534">
                 <a:solidFill>
                   <a:srgbClr val="0F172A"/>
                 </a:solidFill>
@@ -17353,7 +17353,7 @@
               </a:spcAft>
             </a:pPr>
             <a:r>
-              <a:rPr sz="1300" b="0">
+              <a:rPr sz="1534" b="0">
                 <a:solidFill>
                   <a:srgbClr val="2563EB"/>
                 </a:solidFill>
@@ -17362,7 +17362,7 @@
               <a:t>–  </a:t>
             </a:r>
             <a:r>
-              <a:rPr sz="1300">
+              <a:rPr sz="1534">
                 <a:solidFill>
                   <a:srgbClr val="0F172A"/>
                 </a:solidFill>
@@ -17407,7 +17407,7 @@
               </a:spcAft>
             </a:pPr>
             <a:r>
-              <a:rPr sz="900" b="0" i="0">
+              <a:rPr sz="1238" b="0" i="0">
                 <a:solidFill>
                   <a:srgbClr val="64748B"/>
                 </a:solidFill>
@@ -17452,7 +17452,7 @@
               </a:spcAft>
             </a:pPr>
             <a:r>
-              <a:rPr sz="900" b="0" i="0">
+              <a:rPr sz="1238" b="0" i="0">
                 <a:solidFill>
                   <a:srgbClr val="64748B"/>
                 </a:solidFill>
@@ -17559,7 +17559,7 @@
               </a:spcAft>
             </a:pPr>
             <a:r>
-              <a:rPr sz="1250" b="1" i="0">
+              <a:rPr sz="1652" b="1" i="0">
                 <a:solidFill>
                   <a:srgbClr val="2563EB"/>
                 </a:solidFill>
@@ -17739,7 +17739,7 @@
               </a:spcAft>
             </a:pPr>
             <a:r>
-              <a:rPr sz="1400" b="1" i="0">
+              <a:rPr sz="1652" b="1" i="0">
                 <a:solidFill>
                   <a:srgbClr val="16A34A"/>
                 </a:solidFill>
@@ -17784,7 +17784,7 @@
               </a:spcAft>
             </a:pPr>
             <a:r>
-              <a:rPr sz="1250" b="0" i="0">
+              <a:rPr sz="1593" b="0" i="0">
                 <a:solidFill>
                   <a:srgbClr val="0F172A"/>
                 </a:solidFill>
@@ -17919,7 +17919,7 @@
               </a:spcAft>
             </a:pPr>
             <a:r>
-              <a:rPr sz="1400" b="1" i="0">
+              <a:rPr sz="1652" b="1" i="0">
                 <a:solidFill>
                   <a:srgbClr val="16A34A"/>
                 </a:solidFill>
@@ -17964,7 +17964,7 @@
               </a:spcAft>
             </a:pPr>
             <a:r>
-              <a:rPr sz="1250" b="0" i="0">
+              <a:rPr sz="1593" b="0" i="0">
                 <a:solidFill>
                   <a:srgbClr val="0F172A"/>
                 </a:solidFill>
@@ -18099,7 +18099,7 @@
               </a:spcAft>
             </a:pPr>
             <a:r>
-              <a:rPr sz="1400" b="1" i="0">
+              <a:rPr sz="1652" b="1" i="0">
                 <a:solidFill>
                   <a:srgbClr val="16A34A"/>
                 </a:solidFill>
@@ -18144,7 +18144,7 @@
               </a:spcAft>
             </a:pPr>
             <a:r>
-              <a:rPr sz="1250" b="0" i="0">
+              <a:rPr sz="1593" b="0" i="0">
                 <a:solidFill>
                   <a:srgbClr val="0F172A"/>
                 </a:solidFill>
@@ -18189,7 +18189,7 @@
               </a:spcAft>
             </a:pPr>
             <a:r>
-              <a:rPr sz="1200" b="1" i="0">
+              <a:rPr sz="1534" b="1" i="0">
                 <a:solidFill>
                   <a:srgbClr val="2563EB"/>
                 </a:solidFill>
@@ -18234,7 +18234,7 @@
               </a:spcAft>
             </a:pPr>
             <a:r>
-              <a:rPr sz="1350" b="0">
+              <a:rPr sz="1593" b="0">
                 <a:solidFill>
                   <a:srgbClr val="2563EB"/>
                 </a:solidFill>
@@ -18243,7 +18243,7 @@
               <a:t>–  </a:t>
             </a:r>
             <a:r>
-              <a:rPr sz="1350">
+              <a:rPr sz="1593">
                 <a:solidFill>
                   <a:srgbClr val="0F172A"/>
                 </a:solidFill>
@@ -18265,7 +18265,7 @@
               </a:spcAft>
             </a:pPr>
             <a:r>
-              <a:rPr sz="1350" b="0">
+              <a:rPr sz="1593" b="0">
                 <a:solidFill>
                   <a:srgbClr val="2563EB"/>
                 </a:solidFill>
@@ -18274,7 +18274,7 @@
               <a:t>–  </a:t>
             </a:r>
             <a:r>
-              <a:rPr sz="1350">
+              <a:rPr sz="1593">
                 <a:solidFill>
                   <a:srgbClr val="0F172A"/>
                 </a:solidFill>
@@ -18296,7 +18296,7 @@
               </a:spcAft>
             </a:pPr>
             <a:r>
-              <a:rPr sz="1350" b="0">
+              <a:rPr sz="1593" b="0">
                 <a:solidFill>
                   <a:srgbClr val="2563EB"/>
                 </a:solidFill>
@@ -18305,7 +18305,7 @@
               <a:t>–  </a:t>
             </a:r>
             <a:r>
-              <a:rPr sz="1350">
+              <a:rPr sz="1593">
                 <a:solidFill>
                   <a:srgbClr val="0F172A"/>
                 </a:solidFill>
@@ -18327,7 +18327,7 @@
               </a:spcAft>
             </a:pPr>
             <a:r>
-              <a:rPr sz="1350" b="0">
+              <a:rPr sz="1593" b="0">
                 <a:solidFill>
                   <a:srgbClr val="2563EB"/>
                 </a:solidFill>
@@ -18336,7 +18336,7 @@
               <a:t>–  </a:t>
             </a:r>
             <a:r>
-              <a:rPr sz="1350">
+              <a:rPr sz="1593">
                 <a:solidFill>
                   <a:srgbClr val="0F172A"/>
                 </a:solidFill>
@@ -18381,7 +18381,7 @@
               </a:spcAft>
             </a:pPr>
             <a:r>
-              <a:rPr sz="900" b="0" i="0">
+              <a:rPr sz="1238" b="0" i="0">
                 <a:solidFill>
                   <a:srgbClr val="64748B"/>
                 </a:solidFill>
@@ -18426,7 +18426,7 @@
               </a:spcAft>
             </a:pPr>
             <a:r>
-              <a:rPr sz="900" b="0" i="0">
+              <a:rPr sz="1238" b="0" i="0">
                 <a:solidFill>
                   <a:srgbClr val="64748B"/>
                 </a:solidFill>
@@ -18533,7 +18533,7 @@
               </a:spcAft>
             </a:pPr>
             <a:r>
-              <a:rPr sz="1250" b="1" i="0">
+              <a:rPr sz="1652" b="1" i="0">
                 <a:solidFill>
                   <a:srgbClr val="2563EB"/>
                 </a:solidFill>
@@ -18713,7 +18713,7 @@
               </a:spcAft>
             </a:pPr>
             <a:r>
-              <a:rPr sz="1600" b="1" i="0">
+              <a:rPr sz="1888" b="1" i="0">
                 <a:solidFill>
                   <a:srgbClr val="D97706"/>
                 </a:solidFill>
@@ -18758,7 +18758,7 @@
               </a:spcAft>
             </a:pPr>
             <a:r>
-              <a:rPr sz="1250" b="0">
+              <a:rPr sz="1475" b="0">
                 <a:solidFill>
                   <a:srgbClr val="D97706"/>
                 </a:solidFill>
@@ -18767,7 +18767,7 @@
               <a:t>–  </a:t>
             </a:r>
             <a:r>
-              <a:rPr sz="1250">
+              <a:rPr sz="1475">
                 <a:solidFill>
                   <a:srgbClr val="0F172A"/>
                 </a:solidFill>
@@ -18789,7 +18789,7 @@
               </a:spcAft>
             </a:pPr>
             <a:r>
-              <a:rPr sz="1250" b="0">
+              <a:rPr sz="1475" b="0">
                 <a:solidFill>
                   <a:srgbClr val="D97706"/>
                 </a:solidFill>
@@ -18798,7 +18798,7 @@
               <a:t>–  </a:t>
             </a:r>
             <a:r>
-              <a:rPr sz="1250">
+              <a:rPr sz="1475">
                 <a:solidFill>
                   <a:srgbClr val="0F172A"/>
                 </a:solidFill>
@@ -18820,7 +18820,7 @@
               </a:spcAft>
             </a:pPr>
             <a:r>
-              <a:rPr sz="1250" b="0">
+              <a:rPr sz="1475" b="0">
                 <a:solidFill>
                   <a:srgbClr val="D97706"/>
                 </a:solidFill>
@@ -18829,7 +18829,7 @@
               <a:t>–  </a:t>
             </a:r>
             <a:r>
-              <a:rPr sz="1250">
+              <a:rPr sz="1475">
                 <a:solidFill>
                   <a:srgbClr val="0F172A"/>
                 </a:solidFill>
@@ -18851,7 +18851,7 @@
               </a:spcAft>
             </a:pPr>
             <a:r>
-              <a:rPr sz="1250" b="0">
+              <a:rPr sz="1475" b="0">
                 <a:solidFill>
                   <a:srgbClr val="D97706"/>
                 </a:solidFill>
@@ -18860,7 +18860,7 @@
               <a:t>–  </a:t>
             </a:r>
             <a:r>
-              <a:rPr sz="1250">
+              <a:rPr sz="1475">
                 <a:solidFill>
                   <a:srgbClr val="0F172A"/>
                 </a:solidFill>
@@ -18995,7 +18995,7 @@
               </a:spcAft>
             </a:pPr>
             <a:r>
-              <a:rPr sz="1600" b="1" i="0">
+              <a:rPr sz="1888" b="1" i="0">
                 <a:solidFill>
                   <a:srgbClr val="2563EB"/>
                 </a:solidFill>
@@ -19040,7 +19040,7 @@
               </a:spcAft>
             </a:pPr>
             <a:r>
-              <a:rPr sz="1250" b="0">
+              <a:rPr sz="1475" b="0">
                 <a:solidFill>
                   <a:srgbClr val="2563EB"/>
                 </a:solidFill>
@@ -19049,7 +19049,7 @@
               <a:t>–  </a:t>
             </a:r>
             <a:r>
-              <a:rPr sz="1250">
+              <a:rPr sz="1475">
                 <a:solidFill>
                   <a:srgbClr val="0F172A"/>
                 </a:solidFill>
@@ -19071,7 +19071,7 @@
               </a:spcAft>
             </a:pPr>
             <a:r>
-              <a:rPr sz="1250" b="0">
+              <a:rPr sz="1475" b="0">
                 <a:solidFill>
                   <a:srgbClr val="2563EB"/>
                 </a:solidFill>
@@ -19080,7 +19080,7 @@
               <a:t>–  </a:t>
             </a:r>
             <a:r>
-              <a:rPr sz="1250">
+              <a:rPr sz="1475">
                 <a:solidFill>
                   <a:srgbClr val="0F172A"/>
                 </a:solidFill>
@@ -19102,7 +19102,7 @@
               </a:spcAft>
             </a:pPr>
             <a:r>
-              <a:rPr sz="1250" b="0">
+              <a:rPr sz="1475" b="0">
                 <a:solidFill>
                   <a:srgbClr val="2563EB"/>
                 </a:solidFill>
@@ -19111,7 +19111,7 @@
               <a:t>–  </a:t>
             </a:r>
             <a:r>
-              <a:rPr sz="1250">
+              <a:rPr sz="1475">
                 <a:solidFill>
                   <a:srgbClr val="0F172A"/>
                 </a:solidFill>
@@ -19133,7 +19133,7 @@
               </a:spcAft>
             </a:pPr>
             <a:r>
-              <a:rPr sz="1250" b="0">
+              <a:rPr sz="1475" b="0">
                 <a:solidFill>
                   <a:srgbClr val="2563EB"/>
                 </a:solidFill>
@@ -19142,7 +19142,7 @@
               <a:t>–  </a:t>
             </a:r>
             <a:r>
-              <a:rPr sz="1250">
+              <a:rPr sz="1475">
                 <a:solidFill>
                   <a:srgbClr val="0F172A"/>
                 </a:solidFill>
@@ -19231,7 +19231,7 @@
               </a:spcAft>
             </a:pPr>
             <a:r>
-              <a:rPr sz="1350" b="1" i="0">
+              <a:rPr sz="1593" b="1" i="0">
                 <a:solidFill>
                   <a:srgbClr val="FFFFFF"/>
                 </a:solidFill>
@@ -19276,7 +19276,7 @@
               </a:spcAft>
             </a:pPr>
             <a:r>
-              <a:rPr sz="900" b="0" i="0">
+              <a:rPr sz="1238" b="0" i="0">
                 <a:solidFill>
                   <a:srgbClr val="64748B"/>
                 </a:solidFill>
@@ -19321,7 +19321,7 @@
               </a:spcAft>
             </a:pPr>
             <a:r>
-              <a:rPr sz="900" b="0" i="0">
+              <a:rPr sz="1238" b="0" i="0">
                 <a:solidFill>
                   <a:srgbClr val="64748B"/>
                 </a:solidFill>
@@ -19428,7 +19428,7 @@
               </a:spcAft>
             </a:pPr>
             <a:r>
-              <a:rPr sz="1250" b="1" i="0">
+              <a:rPr sz="1652" b="1" i="0">
                 <a:solidFill>
                   <a:srgbClr val="2563EB"/>
                 </a:solidFill>
@@ -19653,7 +19653,7 @@
               </a:spcAft>
             </a:pPr>
             <a:r>
-              <a:rPr sz="1200" b="0" i="0">
+              <a:rPr sz="1534" b="0" i="0">
                 <a:solidFill>
                   <a:srgbClr val="0F172A"/>
                 </a:solidFill>
@@ -19675,7 +19675,7 @@
               </a:spcAft>
             </a:pPr>
             <a:r>
-              <a:rPr sz="1200" b="0" i="0">
+              <a:rPr sz="1534" b="0" i="0">
                 <a:solidFill>
                   <a:srgbClr val="0F172A"/>
                 </a:solidFill>
@@ -19855,7 +19855,7 @@
               </a:spcAft>
             </a:pPr>
             <a:r>
-              <a:rPr sz="1200" b="0" i="0">
+              <a:rPr sz="1534" b="0" i="0">
                 <a:solidFill>
                   <a:srgbClr val="0F172A"/>
                 </a:solidFill>
@@ -19877,7 +19877,7 @@
               </a:spcAft>
             </a:pPr>
             <a:r>
-              <a:rPr sz="1200" b="0" i="0">
+              <a:rPr sz="1534" b="0" i="0">
                 <a:solidFill>
                   <a:srgbClr val="0F172A"/>
                 </a:solidFill>
@@ -20057,7 +20057,7 @@
               </a:spcAft>
             </a:pPr>
             <a:r>
-              <a:rPr sz="1200" b="0" i="0">
+              <a:rPr sz="1534" b="0" i="0">
                 <a:solidFill>
                   <a:srgbClr val="0F172A"/>
                 </a:solidFill>
@@ -20079,7 +20079,7 @@
               </a:spcAft>
             </a:pPr>
             <a:r>
-              <a:rPr sz="1200" b="0" i="0">
+              <a:rPr sz="1534" b="0" i="0">
                 <a:solidFill>
                   <a:srgbClr val="0F172A"/>
                 </a:solidFill>
@@ -20259,7 +20259,7 @@
               </a:spcAft>
             </a:pPr>
             <a:r>
-              <a:rPr sz="1200" b="0" i="0">
+              <a:rPr sz="1534" b="0" i="0">
                 <a:solidFill>
                   <a:srgbClr val="0F172A"/>
                 </a:solidFill>
@@ -20281,7 +20281,7 @@
               </a:spcAft>
             </a:pPr>
             <a:r>
-              <a:rPr sz="1200" b="0" i="0">
+              <a:rPr sz="1534" b="0" i="0">
                 <a:solidFill>
                   <a:srgbClr val="0F172A"/>
                 </a:solidFill>
@@ -20326,7 +20326,7 @@
               </a:spcAft>
             </a:pPr>
             <a:r>
-              <a:rPr sz="1500" b="0">
+              <a:rPr sz="1770" b="0">
                 <a:solidFill>
                   <a:srgbClr val="2563EB"/>
                 </a:solidFill>
@@ -20335,7 +20335,7 @@
               <a:t>–  </a:t>
             </a:r>
             <a:r>
-              <a:rPr sz="1500">
+              <a:rPr sz="1770">
                 <a:solidFill>
                   <a:srgbClr val="0F172A"/>
                 </a:solidFill>
@@ -20357,7 +20357,7 @@
               </a:spcAft>
             </a:pPr>
             <a:r>
-              <a:rPr sz="1500" b="0">
+              <a:rPr sz="1770" b="0">
                 <a:solidFill>
                   <a:srgbClr val="2563EB"/>
                 </a:solidFill>
@@ -20366,7 +20366,7 @@
               <a:t>–  </a:t>
             </a:r>
             <a:r>
-              <a:rPr sz="1500">
+              <a:rPr sz="1770">
                 <a:solidFill>
                   <a:srgbClr val="0F172A"/>
                 </a:solidFill>
@@ -20388,7 +20388,7 @@
               </a:spcAft>
             </a:pPr>
             <a:r>
-              <a:rPr sz="1500" b="0">
+              <a:rPr sz="1770" b="0">
                 <a:solidFill>
                   <a:srgbClr val="2563EB"/>
                 </a:solidFill>
@@ -20397,7 +20397,7 @@
               <a:t>–  </a:t>
             </a:r>
             <a:r>
-              <a:rPr sz="1500">
+              <a:rPr sz="1770">
                 <a:solidFill>
                   <a:srgbClr val="0F172A"/>
                 </a:solidFill>
@@ -20442,7 +20442,7 @@
               </a:spcAft>
             </a:pPr>
             <a:r>
-              <a:rPr sz="950" b="0" i="1">
+              <a:rPr sz="1297" b="0" i="1">
                 <a:solidFill>
                   <a:srgbClr val="64748B"/>
                 </a:solidFill>
@@ -20487,7 +20487,7 @@
               </a:spcAft>
             </a:pPr>
             <a:r>
-              <a:rPr sz="900" b="0" i="0">
+              <a:rPr sz="1238" b="0" i="0">
                 <a:solidFill>
                   <a:srgbClr val="64748B"/>
                 </a:solidFill>
@@ -20532,7 +20532,7 @@
               </a:spcAft>
             </a:pPr>
             <a:r>
-              <a:rPr sz="900" b="0" i="0">
+              <a:rPr sz="1238" b="0" i="0">
                 <a:solidFill>
                   <a:srgbClr val="64748B"/>
                 </a:solidFill>
@@ -20639,7 +20639,7 @@
               </a:spcAft>
             </a:pPr>
             <a:r>
-              <a:rPr sz="1250" b="1" i="0">
+              <a:rPr sz="1652" b="1" i="0">
                 <a:solidFill>
                   <a:srgbClr val="2563EB"/>
                 </a:solidFill>
@@ -20729,7 +20729,7 @@
               </a:spcAft>
             </a:pPr>
             <a:r>
-              <a:rPr sz="1050">
+              <a:rPr sz="1356">
                 <a:solidFill>
                   <a:srgbClr val="0F172A"/>
                 </a:solidFill>
@@ -20751,7 +20751,7 @@
               </a:spcAft>
             </a:pPr>
             <a:r>
-              <a:rPr sz="1050">
+              <a:rPr sz="1356">
                 <a:solidFill>
                   <a:srgbClr val="0F172A"/>
                 </a:solidFill>
@@ -20773,7 +20773,7 @@
               </a:spcAft>
             </a:pPr>
             <a:r>
-              <a:rPr sz="1050">
+              <a:rPr sz="1356">
                 <a:solidFill>
                   <a:srgbClr val="0F172A"/>
                 </a:solidFill>
@@ -20795,7 +20795,7 @@
               </a:spcAft>
             </a:pPr>
             <a:r>
-              <a:rPr sz="1050">
+              <a:rPr sz="1356">
                 <a:solidFill>
                   <a:srgbClr val="0F172A"/>
                 </a:solidFill>
@@ -20817,7 +20817,7 @@
               </a:spcAft>
             </a:pPr>
             <a:r>
-              <a:rPr sz="1050">
+              <a:rPr sz="1356">
                 <a:solidFill>
                   <a:srgbClr val="0F172A"/>
                 </a:solidFill>
@@ -20839,7 +20839,7 @@
               </a:spcAft>
             </a:pPr>
             <a:r>
-              <a:rPr sz="1050">
+              <a:rPr sz="1356">
                 <a:solidFill>
                   <a:srgbClr val="0F172A"/>
                 </a:solidFill>
@@ -20861,7 +20861,7 @@
               </a:spcAft>
             </a:pPr>
             <a:r>
-              <a:rPr sz="1050">
+              <a:rPr sz="1356">
                 <a:solidFill>
                   <a:srgbClr val="0F172A"/>
                 </a:solidFill>
@@ -20883,7 +20883,7 @@
               </a:spcAft>
             </a:pPr>
             <a:r>
-              <a:rPr sz="1050">
+              <a:rPr sz="1356">
                 <a:solidFill>
                   <a:srgbClr val="0F172A"/>
                 </a:solidFill>
@@ -20928,7 +20928,7 @@
               </a:spcAft>
             </a:pPr>
             <a:r>
-              <a:rPr sz="1050">
+              <a:rPr sz="1356">
                 <a:solidFill>
                   <a:srgbClr val="0F172A"/>
                 </a:solidFill>
@@ -20950,7 +20950,7 @@
               </a:spcAft>
             </a:pPr>
             <a:r>
-              <a:rPr sz="1050">
+              <a:rPr sz="1356">
                 <a:solidFill>
                   <a:srgbClr val="0F172A"/>
                 </a:solidFill>
@@ -20972,7 +20972,7 @@
               </a:spcAft>
             </a:pPr>
             <a:r>
-              <a:rPr sz="1050">
+              <a:rPr sz="1356">
                 <a:solidFill>
                   <a:srgbClr val="0F172A"/>
                 </a:solidFill>
@@ -20994,7 +20994,7 @@
               </a:spcAft>
             </a:pPr>
             <a:r>
-              <a:rPr sz="1050">
+              <a:rPr sz="1356">
                 <a:solidFill>
                   <a:srgbClr val="0F172A"/>
                 </a:solidFill>
@@ -21016,7 +21016,7 @@
               </a:spcAft>
             </a:pPr>
             <a:r>
-              <a:rPr sz="1050">
+              <a:rPr sz="1356">
                 <a:solidFill>
                   <a:srgbClr val="0F172A"/>
                 </a:solidFill>
@@ -21038,7 +21038,7 @@
               </a:spcAft>
             </a:pPr>
             <a:r>
-              <a:rPr sz="1050">
+              <a:rPr sz="1356">
                 <a:solidFill>
                   <a:srgbClr val="0F172A"/>
                 </a:solidFill>
@@ -21060,7 +21060,7 @@
               </a:spcAft>
             </a:pPr>
             <a:r>
-              <a:rPr sz="1050">
+              <a:rPr sz="1356">
                 <a:solidFill>
                   <a:srgbClr val="0F172A"/>
                 </a:solidFill>
@@ -21082,7 +21082,7 @@
               </a:spcAft>
             </a:pPr>
             <a:r>
-              <a:rPr sz="1050">
+              <a:rPr sz="1356">
                 <a:solidFill>
                   <a:srgbClr val="0F172A"/>
                 </a:solidFill>
@@ -21127,7 +21127,7 @@
               </a:spcAft>
             </a:pPr>
             <a:r>
-              <a:rPr sz="900" b="0" i="0">
+              <a:rPr sz="1238" b="0" i="0">
                 <a:solidFill>
                   <a:srgbClr val="64748B"/>
                 </a:solidFill>
@@ -21172,7 +21172,7 @@
               </a:spcAft>
             </a:pPr>
             <a:r>
-              <a:rPr sz="900" b="0" i="0">
+              <a:rPr sz="1238" b="0" i="0">
                 <a:solidFill>
                   <a:srgbClr val="64748B"/>
                 </a:solidFill>
@@ -21279,7 +21279,7 @@
               </a:spcAft>
             </a:pPr>
             <a:r>
-              <a:rPr sz="1250" b="1" i="0">
+              <a:rPr sz="1652" b="1" i="0">
                 <a:solidFill>
                   <a:srgbClr val="2563EB"/>
                 </a:solidFill>
@@ -21413,7 +21413,7 @@
               </a:spcAft>
             </a:pPr>
             <a:r>
-              <a:rPr sz="1600" b="1" i="1">
+              <a:rPr sz="1888" b="1" i="1">
                 <a:solidFill>
                   <a:srgbClr val="FFFFFF"/>
                 </a:solidFill>
@@ -21548,7 +21548,7 @@
               </a:spcAft>
             </a:pPr>
             <a:r>
-              <a:rPr sz="1600" b="1" i="0">
+              <a:rPr sz="1888" b="1" i="0">
                 <a:solidFill>
                   <a:srgbClr val="DC2626"/>
                 </a:solidFill>
@@ -21593,7 +21593,7 @@
               </a:spcAft>
             </a:pPr>
             <a:r>
-              <a:rPr sz="1250" b="0" i="0">
+              <a:rPr sz="1593" b="0" i="0">
                 <a:solidFill>
                   <a:srgbClr val="0F172A"/>
                 </a:solidFill>
@@ -21615,7 +21615,7 @@
               </a:spcAft>
             </a:pPr>
             <a:r>
-              <a:rPr sz="1250" b="0" i="0">
+              <a:rPr sz="1593" b="0" i="0">
                 <a:solidFill>
                   <a:srgbClr val="0F172A"/>
                 </a:solidFill>
@@ -21750,7 +21750,7 @@
               </a:spcAft>
             </a:pPr>
             <a:r>
-              <a:rPr sz="1600" b="1" i="0">
+              <a:rPr sz="1888" b="1" i="0">
                 <a:solidFill>
                   <a:srgbClr val="2563EB"/>
                 </a:solidFill>
@@ -21795,7 +21795,7 @@
               </a:spcAft>
             </a:pPr>
             <a:r>
-              <a:rPr sz="1250" b="0" i="0">
+              <a:rPr sz="1593" b="0" i="0">
                 <a:solidFill>
                   <a:srgbClr val="0F172A"/>
                 </a:solidFill>
@@ -21817,7 +21817,7 @@
               </a:spcAft>
             </a:pPr>
             <a:r>
-              <a:rPr sz="1250" b="0" i="0">
+              <a:rPr sz="1593" b="0" i="0">
                 <a:solidFill>
                   <a:srgbClr val="0F172A"/>
                 </a:solidFill>
@@ -21952,7 +21952,7 @@
               </a:spcAft>
             </a:pPr>
             <a:r>
-              <a:rPr sz="1600" b="1" i="0">
+              <a:rPr sz="1888" b="1" i="0">
                 <a:solidFill>
                   <a:srgbClr val="06B6D4"/>
                 </a:solidFill>
@@ -21997,7 +21997,7 @@
               </a:spcAft>
             </a:pPr>
             <a:r>
-              <a:rPr sz="1250" b="0" i="0">
+              <a:rPr sz="1593" b="0" i="0">
                 <a:solidFill>
                   <a:srgbClr val="0F172A"/>
                 </a:solidFill>
@@ -22019,7 +22019,7 @@
               </a:spcAft>
             </a:pPr>
             <a:r>
-              <a:rPr sz="1250" b="0" i="0">
+              <a:rPr sz="1593" b="0" i="0">
                 <a:solidFill>
                   <a:srgbClr val="0F172A"/>
                 </a:solidFill>
@@ -22064,7 +22064,7 @@
               </a:spcAft>
             </a:pPr>
             <a:r>
-              <a:rPr sz="1200" b="1" i="0">
+              <a:rPr sz="1534" b="1" i="0">
                 <a:solidFill>
                   <a:srgbClr val="2563EB"/>
                 </a:solidFill>
@@ -22153,7 +22153,7 @@
               </a:spcAft>
             </a:pPr>
             <a:r>
-              <a:rPr sz="1350" b="1" i="0">
+              <a:rPr sz="1593" b="1" i="0">
                 <a:solidFill>
                   <a:srgbClr val="FFFFFF"/>
                 </a:solidFill>
@@ -22198,7 +22198,7 @@
               </a:spcAft>
             </a:pPr>
             <a:r>
-              <a:rPr sz="1800" b="1" i="0">
+              <a:rPr sz="2124" b="1" i="0">
                 <a:solidFill>
                   <a:srgbClr val="64748B"/>
                 </a:solidFill>
@@ -22287,7 +22287,7 @@
               </a:spcAft>
             </a:pPr>
             <a:r>
-              <a:rPr sz="1350" b="1" i="0">
+              <a:rPr sz="1593" b="1" i="0">
                 <a:solidFill>
                   <a:srgbClr val="FFFFFF"/>
                 </a:solidFill>
@@ -22332,7 +22332,7 @@
               </a:spcAft>
             </a:pPr>
             <a:r>
-              <a:rPr sz="1800" b="1" i="0">
+              <a:rPr sz="2124" b="1" i="0">
                 <a:solidFill>
                   <a:srgbClr val="64748B"/>
                 </a:solidFill>
@@ -22421,7 +22421,7 @@
               </a:spcAft>
             </a:pPr>
             <a:r>
-              <a:rPr sz="1350" b="1" i="0">
+              <a:rPr sz="1593" b="1" i="0">
                 <a:solidFill>
                   <a:srgbClr val="FFFFFF"/>
                 </a:solidFill>
@@ -22466,7 +22466,7 @@
               </a:spcAft>
             </a:pPr>
             <a:r>
-              <a:rPr sz="1800" b="1" i="0">
+              <a:rPr sz="2124" b="1" i="0">
                 <a:solidFill>
                   <a:srgbClr val="64748B"/>
                 </a:solidFill>
@@ -22555,7 +22555,7 @@
               </a:spcAft>
             </a:pPr>
             <a:r>
-              <a:rPr sz="1350" b="1" i="0">
+              <a:rPr sz="1593" b="1" i="0">
                 <a:solidFill>
                   <a:srgbClr val="FFFFFF"/>
                 </a:solidFill>
@@ -22600,7 +22600,7 @@
               </a:spcAft>
             </a:pPr>
             <a:r>
-              <a:rPr sz="1400" b="1" i="0">
+              <a:rPr sz="1652" b="1" i="0">
                 <a:solidFill>
                   <a:srgbClr val="0F172A"/>
                 </a:solidFill>
@@ -22645,7 +22645,7 @@
               </a:spcAft>
             </a:pPr>
             <a:r>
-              <a:rPr sz="900" b="0" i="0">
+              <a:rPr sz="1238" b="0" i="0">
                 <a:solidFill>
                   <a:srgbClr val="64748B"/>
                 </a:solidFill>
@@ -22690,7 +22690,7 @@
               </a:spcAft>
             </a:pPr>
             <a:r>
-              <a:rPr sz="900" b="0" i="0">
+              <a:rPr sz="1238" b="0" i="0">
                 <a:solidFill>
                   <a:srgbClr val="64748B"/>
                 </a:solidFill>
@@ -22797,7 +22797,7 @@
               </a:spcAft>
             </a:pPr>
             <a:r>
-              <a:rPr sz="1250" b="1" i="0">
+              <a:rPr sz="1652" b="1" i="0">
                 <a:solidFill>
                   <a:srgbClr val="2563EB"/>
                 </a:solidFill>
@@ -22977,7 +22977,7 @@
               </a:spcAft>
             </a:pPr>
             <a:r>
-              <a:rPr sz="1450" b="1" i="0">
+              <a:rPr sz="1711" b="1" i="0">
                 <a:solidFill>
                   <a:srgbClr val="0F172A"/>
                 </a:solidFill>
@@ -23022,7 +23022,7 @@
               </a:spcAft>
             </a:pPr>
             <a:r>
-              <a:rPr sz="1150" b="1" i="1">
+              <a:rPr sz="1534" b="1" i="1">
                 <a:solidFill>
                   <a:srgbClr val="DC2626"/>
                 </a:solidFill>
@@ -23067,7 +23067,7 @@
               </a:spcAft>
             </a:pPr>
             <a:r>
-              <a:rPr sz="1200" b="0" i="0">
+              <a:rPr sz="1593" b="0" i="0">
                 <a:solidFill>
                   <a:srgbClr val="0F172A"/>
                 </a:solidFill>
@@ -23202,7 +23202,7 @@
               </a:spcAft>
             </a:pPr>
             <a:r>
-              <a:rPr sz="1450" b="1" i="0">
+              <a:rPr sz="1711" b="1" i="0">
                 <a:solidFill>
                   <a:srgbClr val="0F172A"/>
                 </a:solidFill>
@@ -23247,7 +23247,7 @@
               </a:spcAft>
             </a:pPr>
             <a:r>
-              <a:rPr sz="1150" b="1" i="1">
+              <a:rPr sz="1534" b="1" i="1">
                 <a:solidFill>
                   <a:srgbClr val="DC2626"/>
                 </a:solidFill>
@@ -23292,7 +23292,7 @@
               </a:spcAft>
             </a:pPr>
             <a:r>
-              <a:rPr sz="1200" b="0" i="0">
+              <a:rPr sz="1593" b="0" i="0">
                 <a:solidFill>
                   <a:srgbClr val="0F172A"/>
                 </a:solidFill>
@@ -23427,7 +23427,7 @@
               </a:spcAft>
             </a:pPr>
             <a:r>
-              <a:rPr sz="1450" b="1" i="0">
+              <a:rPr sz="1711" b="1" i="0">
                 <a:solidFill>
                   <a:srgbClr val="0F172A"/>
                 </a:solidFill>
@@ -23472,7 +23472,7 @@
               </a:spcAft>
             </a:pPr>
             <a:r>
-              <a:rPr sz="1150" b="1" i="1">
+              <a:rPr sz="1534" b="1" i="1">
                 <a:solidFill>
                   <a:srgbClr val="2563EB"/>
                 </a:solidFill>
@@ -23517,7 +23517,7 @@
               </a:spcAft>
             </a:pPr>
             <a:r>
-              <a:rPr sz="1200" b="0" i="0">
+              <a:rPr sz="1593" b="0" i="0">
                 <a:solidFill>
                   <a:srgbClr val="0F172A"/>
                 </a:solidFill>
@@ -23652,7 +23652,7 @@
               </a:spcAft>
             </a:pPr>
             <a:r>
-              <a:rPr sz="1450" b="1" i="0">
+              <a:rPr sz="1711" b="1" i="0">
                 <a:solidFill>
                   <a:srgbClr val="0F172A"/>
                 </a:solidFill>
@@ -23697,7 +23697,7 @@
               </a:spcAft>
             </a:pPr>
             <a:r>
-              <a:rPr sz="1150" b="1" i="1">
+              <a:rPr sz="1534" b="1" i="1">
                 <a:solidFill>
                   <a:srgbClr val="DC2626"/>
                 </a:solidFill>
@@ -23742,7 +23742,7 @@
               </a:spcAft>
             </a:pPr>
             <a:r>
-              <a:rPr sz="1200" b="0" i="0">
+              <a:rPr sz="1593" b="0" i="0">
                 <a:solidFill>
                   <a:srgbClr val="0F172A"/>
                 </a:solidFill>
@@ -23877,7 +23877,7 @@
               </a:spcAft>
             </a:pPr>
             <a:r>
-              <a:rPr sz="1450" b="1" i="0">
+              <a:rPr sz="1711" b="1" i="0">
                 <a:solidFill>
                   <a:srgbClr val="0F172A"/>
                 </a:solidFill>
@@ -23922,7 +23922,7 @@
               </a:spcAft>
             </a:pPr>
             <a:r>
-              <a:rPr sz="1150" b="1" i="1">
+              <a:rPr sz="1534" b="1" i="1">
                 <a:solidFill>
                   <a:srgbClr val="06B6D4"/>
                 </a:solidFill>
@@ -23967,7 +23967,7 @@
               </a:spcAft>
             </a:pPr>
             <a:r>
-              <a:rPr sz="1200" b="0" i="0">
+              <a:rPr sz="1593" b="0" i="0">
                 <a:solidFill>
                   <a:srgbClr val="0F172A"/>
                 </a:solidFill>
@@ -24102,7 +24102,7 @@
               </a:spcAft>
             </a:pPr>
             <a:r>
-              <a:rPr sz="1450" b="1" i="0">
+              <a:rPr sz="1711" b="1" i="0">
                 <a:solidFill>
                   <a:srgbClr val="0F172A"/>
                 </a:solidFill>
@@ -24147,7 +24147,7 @@
               </a:spcAft>
             </a:pPr>
             <a:r>
-              <a:rPr sz="1150" b="1" i="1">
+              <a:rPr sz="1534" b="1" i="1">
                 <a:solidFill>
                   <a:srgbClr val="2563EB"/>
                 </a:solidFill>
@@ -24192,7 +24192,7 @@
               </a:spcAft>
             </a:pPr>
             <a:r>
-              <a:rPr sz="1200" b="0" i="0">
+              <a:rPr sz="1593" b="0" i="0">
                 <a:solidFill>
                   <a:srgbClr val="0F172A"/>
                 </a:solidFill>
@@ -24237,7 +24237,7 @@
               </a:spcAft>
             </a:pPr>
             <a:r>
-              <a:rPr sz="900" b="0" i="0">
+              <a:rPr sz="1238" b="0" i="0">
                 <a:solidFill>
                   <a:srgbClr val="64748B"/>
                 </a:solidFill>
@@ -24282,7 +24282,7 @@
               </a:spcAft>
             </a:pPr>
             <a:r>
-              <a:rPr sz="900" b="0" i="0">
+              <a:rPr sz="1238" b="0" i="0">
                 <a:solidFill>
                   <a:srgbClr val="64748B"/>
                 </a:solidFill>
@@ -24389,7 +24389,7 @@
               </a:spcAft>
             </a:pPr>
             <a:r>
-              <a:rPr sz="1250" b="1" i="0">
+              <a:rPr sz="1652" b="1" i="0">
                 <a:solidFill>
                   <a:srgbClr val="2563EB"/>
                 </a:solidFill>
@@ -24523,7 +24523,7 @@
               </a:spcAft>
             </a:pPr>
             <a:r>
-              <a:rPr sz="1300" b="1" i="0">
+              <a:rPr sz="1652" b="1" i="0">
                 <a:solidFill>
                   <a:srgbClr val="FFFFFF"/>
                 </a:solidFill>
@@ -24612,7 +24612,7 @@
               </a:spcAft>
             </a:pPr>
             <a:r>
-              <a:rPr sz="1300" b="1" i="0">
+              <a:rPr sz="1652" b="1" i="0">
                 <a:solidFill>
                   <a:srgbClr val="FFFFFF"/>
                 </a:solidFill>
@@ -24701,7 +24701,7 @@
               </a:spcAft>
             </a:pPr>
             <a:r>
-              <a:rPr sz="1300" b="1" i="0">
+              <a:rPr sz="1652" b="1" i="0">
                 <a:solidFill>
                   <a:srgbClr val="FFFFFF"/>
                 </a:solidFill>
@@ -24790,7 +24790,7 @@
               </a:spcAft>
             </a:pPr>
             <a:r>
-              <a:rPr sz="1300" b="1" i="0">
+              <a:rPr sz="1652" b="1" i="0">
                 <a:solidFill>
                   <a:srgbClr val="FFFFFF"/>
                 </a:solidFill>
@@ -24879,7 +24879,7 @@
               </a:spcAft>
             </a:pPr>
             <a:r>
-              <a:rPr sz="1300" b="1" i="0">
+              <a:rPr sz="1652" b="1" i="0">
                 <a:solidFill>
                   <a:srgbClr val="FFFFFF"/>
                 </a:solidFill>
@@ -24970,7 +24970,7 @@
               </a:spcAft>
             </a:pPr>
             <a:r>
-              <a:rPr sz="1250" b="1" i="0">
+              <a:rPr sz="1652" b="1" i="0">
                 <a:solidFill>
                   <a:srgbClr val="0F172A"/>
                 </a:solidFill>
@@ -25061,7 +25061,7 @@
               </a:spcAft>
             </a:pPr>
             <a:r>
-              <a:rPr sz="1250" b="0" i="0">
+              <a:rPr sz="1652" b="0" i="0">
                 <a:solidFill>
                   <a:srgbClr val="0F172A"/>
                 </a:solidFill>
@@ -25152,7 +25152,7 @@
               </a:spcAft>
             </a:pPr>
             <a:r>
-              <a:rPr sz="1250" b="0" i="0">
+              <a:rPr sz="1652" b="0" i="0">
                 <a:solidFill>
                   <a:srgbClr val="0F172A"/>
                 </a:solidFill>
@@ -25174,7 +25174,7 @@
               </a:spcAft>
             </a:pPr>
             <a:r>
-              <a:rPr sz="1250" b="0" i="0">
+              <a:rPr sz="1652" b="0" i="0">
                 <a:solidFill>
                   <a:srgbClr val="0F172A"/>
                 </a:solidFill>
@@ -25265,7 +25265,7 @@
               </a:spcAft>
             </a:pPr>
             <a:r>
-              <a:rPr sz="1250" b="0" i="0">
+              <a:rPr sz="1652" b="0" i="0">
                 <a:solidFill>
                   <a:srgbClr val="0F172A"/>
                 </a:solidFill>
@@ -25356,7 +25356,7 @@
               </a:spcAft>
             </a:pPr>
             <a:r>
-              <a:rPr sz="1250" b="0" i="0">
+              <a:rPr sz="1652" b="0" i="0">
                 <a:solidFill>
                   <a:srgbClr val="0F172A"/>
                 </a:solidFill>
@@ -25447,7 +25447,7 @@
               </a:spcAft>
             </a:pPr>
             <a:r>
-              <a:rPr sz="1250" b="1" i="0">
+              <a:rPr sz="1652" b="1" i="0">
                 <a:solidFill>
                   <a:srgbClr val="0F172A"/>
                 </a:solidFill>
@@ -25538,7 +25538,7 @@
               </a:spcAft>
             </a:pPr>
             <a:r>
-              <a:rPr sz="1250" b="0" i="0">
+              <a:rPr sz="1652" b="0" i="0">
                 <a:solidFill>
                   <a:srgbClr val="0F172A"/>
                 </a:solidFill>
@@ -25560,7 +25560,7 @@
               </a:spcAft>
             </a:pPr>
             <a:r>
-              <a:rPr sz="1250" b="0" i="0">
+              <a:rPr sz="1652" b="0" i="0">
                 <a:solidFill>
                   <a:srgbClr val="0F172A"/>
                 </a:solidFill>
@@ -25651,7 +25651,7 @@
               </a:spcAft>
             </a:pPr>
             <a:r>
-              <a:rPr sz="1250" b="0" i="0">
+              <a:rPr sz="1652" b="0" i="0">
                 <a:solidFill>
                   <a:srgbClr val="0F172A"/>
                 </a:solidFill>
@@ -25673,7 +25673,7 @@
               </a:spcAft>
             </a:pPr>
             <a:r>
-              <a:rPr sz="1250" b="0" i="0">
+              <a:rPr sz="1652" b="0" i="0">
                 <a:solidFill>
                   <a:srgbClr val="0F172A"/>
                 </a:solidFill>
@@ -25764,7 +25764,7 @@
               </a:spcAft>
             </a:pPr>
             <a:r>
-              <a:rPr sz="1250" b="0" i="0">
+              <a:rPr sz="1652" b="0" i="0">
                 <a:solidFill>
                   <a:srgbClr val="0F172A"/>
                 </a:solidFill>
@@ -25855,7 +25855,7 @@
               </a:spcAft>
             </a:pPr>
             <a:r>
-              <a:rPr sz="1250" b="0" i="0">
+              <a:rPr sz="1652" b="0" i="0">
                 <a:solidFill>
                   <a:srgbClr val="0F172A"/>
                 </a:solidFill>
@@ -25946,7 +25946,7 @@
               </a:spcAft>
             </a:pPr>
             <a:r>
-              <a:rPr sz="1250" b="1" i="0">
+              <a:rPr sz="1652" b="1" i="0">
                 <a:solidFill>
                   <a:srgbClr val="0F172A"/>
                 </a:solidFill>
@@ -26037,7 +26037,7 @@
               </a:spcAft>
             </a:pPr>
             <a:r>
-              <a:rPr sz="1250" b="0" i="0">
+              <a:rPr sz="1652" b="0" i="0">
                 <a:solidFill>
                   <a:srgbClr val="0F172A"/>
                 </a:solidFill>
@@ -26059,7 +26059,7 @@
               </a:spcAft>
             </a:pPr>
             <a:r>
-              <a:rPr sz="1250" b="0" i="0">
+              <a:rPr sz="1652" b="0" i="0">
                 <a:solidFill>
                   <a:srgbClr val="0F172A"/>
                 </a:solidFill>
@@ -26150,7 +26150,7 @@
               </a:spcAft>
             </a:pPr>
             <a:r>
-              <a:rPr sz="1250" b="0" i="0">
+              <a:rPr sz="1652" b="0" i="0">
                 <a:solidFill>
                   <a:srgbClr val="0F172A"/>
                 </a:solidFill>
@@ -26241,7 +26241,7 @@
               </a:spcAft>
             </a:pPr>
             <a:r>
-              <a:rPr sz="1250" b="0" i="0">
+              <a:rPr sz="1652" b="0" i="0">
                 <a:solidFill>
                   <a:srgbClr val="0F172A"/>
                 </a:solidFill>
@@ -26332,7 +26332,7 @@
               </a:spcAft>
             </a:pPr>
             <a:r>
-              <a:rPr sz="1250" b="0" i="0">
+              <a:rPr sz="1652" b="0" i="0">
                 <a:solidFill>
                   <a:srgbClr val="0F172A"/>
                 </a:solidFill>
@@ -26377,7 +26377,7 @@
               </a:spcAft>
             </a:pPr>
             <a:r>
-              <a:rPr sz="1400" b="1" i="0">
+              <a:rPr sz="1652" b="1" i="0">
                 <a:solidFill>
                   <a:srgbClr val="FFFFFF"/>
                 </a:solidFill>
@@ -26422,7 +26422,7 @@
               </a:spcAft>
             </a:pPr>
             <a:r>
-              <a:rPr sz="1400" b="1" i="0">
+              <a:rPr sz="1652" b="1" i="0">
                 <a:solidFill>
                   <a:srgbClr val="FFFFFF"/>
                 </a:solidFill>
@@ -26467,7 +26467,7 @@
               </a:spcAft>
             </a:pPr>
             <a:r>
-              <a:rPr sz="1400" b="1" i="0">
+              <a:rPr sz="1652" b="1" i="0">
                 <a:solidFill>
                   <a:srgbClr val="FFFFFF"/>
                 </a:solidFill>
@@ -26512,7 +26512,7 @@
               </a:spcAft>
             </a:pPr>
             <a:r>
-              <a:rPr sz="1350" b="1" i="0">
+              <a:rPr sz="1593" b="1" i="0">
                 <a:solidFill>
                   <a:srgbClr val="0F172A"/>
                 </a:solidFill>
@@ -26557,7 +26557,7 @@
               </a:spcAft>
             </a:pPr>
             <a:r>
-              <a:rPr sz="950" b="0" i="1">
+              <a:rPr sz="1297" b="0" i="1">
                 <a:solidFill>
                   <a:srgbClr val="64748B"/>
                 </a:solidFill>
@@ -26602,7 +26602,7 @@
               </a:spcAft>
             </a:pPr>
             <a:r>
-              <a:rPr sz="900" b="0" i="0">
+              <a:rPr sz="1238" b="0" i="0">
                 <a:solidFill>
                   <a:srgbClr val="64748B"/>
                 </a:solidFill>
@@ -26647,7 +26647,7 @@
               </a:spcAft>
             </a:pPr>
             <a:r>
-              <a:rPr sz="900" b="0" i="0">
+              <a:rPr sz="1238" b="0" i="0">
                 <a:solidFill>
                   <a:srgbClr val="64748B"/>
                 </a:solidFill>
@@ -26754,7 +26754,7 @@
               </a:spcAft>
             </a:pPr>
             <a:r>
-              <a:rPr sz="1250" b="1" i="0">
+              <a:rPr sz="1652" b="1" i="0">
                 <a:solidFill>
                   <a:srgbClr val="2563EB"/>
                 </a:solidFill>
@@ -26909,7 +26909,7 @@
         <p:spPr>
           <a:xfrm>
             <a:off x="713232" y="1892808"/>
-            <a:ext cx="3264408" cy="365760"/>
+            <a:ext cx="3264408" cy="548640"/>
           </a:xfrm>
           <a:prstGeom prst="rect">
             <a:avLst/>
@@ -26924,7 +26924,7 @@
           <a:p>
             <a:pPr algn="l">
               <a:lnSpc>
-                <a:spcPct val="100000"/>
+                <a:spcPct val="98000"/>
               </a:lnSpc>
               <a:spcBef>
                 <a:spcPts val="0"/>
@@ -26934,7 +26934,7 @@
               </a:spcAft>
             </a:pPr>
             <a:r>
-              <a:rPr sz="1500" b="1" i="0">
+              <a:rPr sz="1888" b="1" i="0">
                 <a:solidFill>
                   <a:srgbClr val="DC2626"/>
                 </a:solidFill>
@@ -26953,8 +26953,8 @@
         </p:nvSpPr>
         <p:spPr>
           <a:xfrm>
-            <a:off x="713232" y="2350008"/>
-            <a:ext cx="3264408" cy="3017520"/>
+            <a:off x="713232" y="2478024"/>
+            <a:ext cx="3264408" cy="2889504"/>
           </a:xfrm>
           <a:prstGeom prst="rect">
             <a:avLst/>
@@ -26979,7 +26979,7 @@
               </a:spcAft>
             </a:pPr>
             <a:r>
-              <a:rPr sz="1200" b="0">
+              <a:rPr sz="1593" b="0">
                 <a:solidFill>
                   <a:srgbClr val="DC2626"/>
                 </a:solidFill>
@@ -26988,7 +26988,7 @@
               <a:t>–  </a:t>
             </a:r>
             <a:r>
-              <a:rPr sz="1200">
+              <a:rPr sz="1593">
                 <a:solidFill>
                   <a:srgbClr val="0F172A"/>
                 </a:solidFill>
@@ -27010,7 +27010,7 @@
               </a:spcAft>
             </a:pPr>
             <a:r>
-              <a:rPr sz="1200" b="0">
+              <a:rPr sz="1593" b="0">
                 <a:solidFill>
                   <a:srgbClr val="DC2626"/>
                 </a:solidFill>
@@ -27019,7 +27019,7 @@
               <a:t>–  </a:t>
             </a:r>
             <a:r>
-              <a:rPr sz="1200">
+              <a:rPr sz="1593">
                 <a:solidFill>
                   <a:srgbClr val="0F172A"/>
                 </a:solidFill>
@@ -27041,7 +27041,7 @@
               </a:spcAft>
             </a:pPr>
             <a:r>
-              <a:rPr sz="1200" b="0">
+              <a:rPr sz="1593" b="0">
                 <a:solidFill>
                   <a:srgbClr val="DC2626"/>
                 </a:solidFill>
@@ -27050,7 +27050,7 @@
               <a:t>–  </a:t>
             </a:r>
             <a:r>
-              <a:rPr sz="1200">
+              <a:rPr sz="1593">
                 <a:solidFill>
                   <a:srgbClr val="0F172A"/>
                 </a:solidFill>
@@ -27072,7 +27072,7 @@
               </a:spcAft>
             </a:pPr>
             <a:r>
-              <a:rPr sz="1200" b="0">
+              <a:rPr sz="1593" b="0">
                 <a:solidFill>
                   <a:srgbClr val="DC2626"/>
                 </a:solidFill>
@@ -27081,7 +27081,7 @@
               <a:t>–  </a:t>
             </a:r>
             <a:r>
-              <a:rPr sz="1200">
+              <a:rPr sz="1593">
                 <a:solidFill>
                   <a:srgbClr val="0F172A"/>
                 </a:solidFill>
@@ -27103,7 +27103,7 @@
               </a:spcAft>
             </a:pPr>
             <a:r>
-              <a:rPr sz="1200" b="0">
+              <a:rPr sz="1593" b="0">
                 <a:solidFill>
                   <a:srgbClr val="DC2626"/>
                 </a:solidFill>
@@ -27112,7 +27112,7 @@
               <a:t>–  </a:t>
             </a:r>
             <a:r>
-              <a:rPr sz="1200">
+              <a:rPr sz="1593">
                 <a:solidFill>
                   <a:srgbClr val="0F172A"/>
                 </a:solidFill>
@@ -27222,7 +27222,7 @@
         <p:spPr>
           <a:xfrm>
             <a:off x="4443984" y="1892808"/>
-            <a:ext cx="3264408" cy="365760"/>
+            <a:ext cx="3264408" cy="548640"/>
           </a:xfrm>
           <a:prstGeom prst="rect">
             <a:avLst/>
@@ -27237,7 +27237,7 @@
           <a:p>
             <a:pPr algn="l">
               <a:lnSpc>
-                <a:spcPct val="100000"/>
+                <a:spcPct val="98000"/>
               </a:lnSpc>
               <a:spcBef>
                 <a:spcPts val="0"/>
@@ -27247,7 +27247,7 @@
               </a:spcAft>
             </a:pPr>
             <a:r>
-              <a:rPr sz="1500" b="1" i="0">
+              <a:rPr sz="1888" b="1" i="0">
                 <a:solidFill>
                   <a:srgbClr val="2563EB"/>
                 </a:solidFill>
@@ -27266,8 +27266,8 @@
         </p:nvSpPr>
         <p:spPr>
           <a:xfrm>
-            <a:off x="4443984" y="2350008"/>
-            <a:ext cx="3264408" cy="3017520"/>
+            <a:off x="4443984" y="2478024"/>
+            <a:ext cx="3264408" cy="2889504"/>
           </a:xfrm>
           <a:prstGeom prst="rect">
             <a:avLst/>
@@ -27292,7 +27292,7 @@
               </a:spcAft>
             </a:pPr>
             <a:r>
-              <a:rPr sz="1200" b="0">
+              <a:rPr sz="1593" b="0">
                 <a:solidFill>
                   <a:srgbClr val="2563EB"/>
                 </a:solidFill>
@@ -27301,7 +27301,7 @@
               <a:t>–  </a:t>
             </a:r>
             <a:r>
-              <a:rPr sz="1200">
+              <a:rPr sz="1593">
                 <a:solidFill>
                   <a:srgbClr val="0F172A"/>
                 </a:solidFill>
@@ -27323,7 +27323,7 @@
               </a:spcAft>
             </a:pPr>
             <a:r>
-              <a:rPr sz="1200" b="0">
+              <a:rPr sz="1593" b="0">
                 <a:solidFill>
                   <a:srgbClr val="2563EB"/>
                 </a:solidFill>
@@ -27332,7 +27332,7 @@
               <a:t>–  </a:t>
             </a:r>
             <a:r>
-              <a:rPr sz="1200">
+              <a:rPr sz="1593">
                 <a:solidFill>
                   <a:srgbClr val="0F172A"/>
                 </a:solidFill>
@@ -27354,7 +27354,7 @@
               </a:spcAft>
             </a:pPr>
             <a:r>
-              <a:rPr sz="1200" b="0">
+              <a:rPr sz="1593" b="0">
                 <a:solidFill>
                   <a:srgbClr val="2563EB"/>
                 </a:solidFill>
@@ -27363,7 +27363,7 @@
               <a:t>–  </a:t>
             </a:r>
             <a:r>
-              <a:rPr sz="1200">
+              <a:rPr sz="1593">
                 <a:solidFill>
                   <a:srgbClr val="0F172A"/>
                 </a:solidFill>
@@ -27385,7 +27385,7 @@
               </a:spcAft>
             </a:pPr>
             <a:r>
-              <a:rPr sz="1200" b="0">
+              <a:rPr sz="1593" b="0">
                 <a:solidFill>
                   <a:srgbClr val="2563EB"/>
                 </a:solidFill>
@@ -27394,7 +27394,7 @@
               <a:t>–  </a:t>
             </a:r>
             <a:r>
-              <a:rPr sz="1200">
+              <a:rPr sz="1593">
                 <a:solidFill>
                   <a:srgbClr val="0F172A"/>
                 </a:solidFill>
@@ -27416,7 +27416,7 @@
               </a:spcAft>
             </a:pPr>
             <a:r>
-              <a:rPr sz="1200" b="0">
+              <a:rPr sz="1593" b="0">
                 <a:solidFill>
                   <a:srgbClr val="2563EB"/>
                 </a:solidFill>
@@ -27425,7 +27425,7 @@
               <a:t>–  </a:t>
             </a:r>
             <a:r>
-              <a:rPr sz="1200">
+              <a:rPr sz="1593">
                 <a:solidFill>
                   <a:srgbClr val="0F172A"/>
                 </a:solidFill>
@@ -27535,7 +27535,7 @@
         <p:spPr>
           <a:xfrm>
             <a:off x="8174736" y="1892808"/>
-            <a:ext cx="3264408" cy="365760"/>
+            <a:ext cx="3264408" cy="548640"/>
           </a:xfrm>
           <a:prstGeom prst="rect">
             <a:avLst/>
@@ -27550,7 +27550,7 @@
           <a:p>
             <a:pPr algn="l">
               <a:lnSpc>
-                <a:spcPct val="100000"/>
+                <a:spcPct val="98000"/>
               </a:lnSpc>
               <a:spcBef>
                 <a:spcPts val="0"/>
@@ -27560,13 +27560,13 @@
               </a:spcAft>
             </a:pPr>
             <a:r>
-              <a:rPr sz="1500" b="1" i="0">
+              <a:rPr sz="1888" b="1" i="0">
                 <a:solidFill>
                   <a:srgbClr val="06B6D4"/>
                 </a:solidFill>
                 <a:latin typeface="Calibri"/>
               </a:rPr>
-              <a:t>Geely — Founder apex, multi-brand</a:t>
+              <a:t>Geely — Founder apex</a:t>
             </a:r>
           </a:p>
         </p:txBody>
@@ -27579,8 +27579,8 @@
         </p:nvSpPr>
         <p:spPr>
           <a:xfrm>
-            <a:off x="8174736" y="2350008"/>
-            <a:ext cx="3264408" cy="3017520"/>
+            <a:off x="8174736" y="2478024"/>
+            <a:ext cx="3264408" cy="2889504"/>
           </a:xfrm>
           <a:prstGeom prst="rect">
             <a:avLst/>
@@ -27605,7 +27605,7 @@
               </a:spcAft>
             </a:pPr>
             <a:r>
-              <a:rPr sz="1200" b="0">
+              <a:rPr sz="1593" b="0">
                 <a:solidFill>
                   <a:srgbClr val="06B6D4"/>
                 </a:solidFill>
@@ -27614,7 +27614,7 @@
               <a:t>–  </a:t>
             </a:r>
             <a:r>
-              <a:rPr sz="1200">
+              <a:rPr sz="1593">
                 <a:solidFill>
                   <a:srgbClr val="0F172A"/>
                 </a:solidFill>
@@ -27636,7 +27636,7 @@
               </a:spcAft>
             </a:pPr>
             <a:r>
-              <a:rPr sz="1200" b="0">
+              <a:rPr sz="1593" b="0">
                 <a:solidFill>
                   <a:srgbClr val="06B6D4"/>
                 </a:solidFill>
@@ -27645,7 +27645,7 @@
               <a:t>–  </a:t>
             </a:r>
             <a:r>
-              <a:rPr sz="1200">
+              <a:rPr sz="1593">
                 <a:solidFill>
                   <a:srgbClr val="0F172A"/>
                 </a:solidFill>
@@ -27667,7 +27667,7 @@
               </a:spcAft>
             </a:pPr>
             <a:r>
-              <a:rPr sz="1200" b="0">
+              <a:rPr sz="1593" b="0">
                 <a:solidFill>
                   <a:srgbClr val="06B6D4"/>
                 </a:solidFill>
@@ -27676,7 +27676,7 @@
               <a:t>–  </a:t>
             </a:r>
             <a:r>
-              <a:rPr sz="1200">
+              <a:rPr sz="1593">
                 <a:solidFill>
                   <a:srgbClr val="0F172A"/>
                 </a:solidFill>
@@ -27698,7 +27698,7 @@
               </a:spcAft>
             </a:pPr>
             <a:r>
-              <a:rPr sz="1200" b="0">
+              <a:rPr sz="1593" b="0">
                 <a:solidFill>
                   <a:srgbClr val="06B6D4"/>
                 </a:solidFill>
@@ -27707,7 +27707,7 @@
               <a:t>–  </a:t>
             </a:r>
             <a:r>
-              <a:rPr sz="1200">
+              <a:rPr sz="1593">
                 <a:solidFill>
                   <a:srgbClr val="0F172A"/>
                 </a:solidFill>
@@ -27729,7 +27729,7 @@
               </a:spcAft>
             </a:pPr>
             <a:r>
-              <a:rPr sz="1200" b="0">
+              <a:rPr sz="1593" b="0">
                 <a:solidFill>
                   <a:srgbClr val="06B6D4"/>
                 </a:solidFill>
@@ -27738,7 +27738,7 @@
               <a:t>–  </a:t>
             </a:r>
             <a:r>
-              <a:rPr sz="1200">
+              <a:rPr sz="1593">
                 <a:solidFill>
                   <a:srgbClr val="0F172A"/>
                 </a:solidFill>
@@ -27783,7 +27783,7 @@
               </a:spcAft>
             </a:pPr>
             <a:r>
-              <a:rPr sz="950" b="0" i="1">
+              <a:rPr sz="1297" b="0" i="1">
                 <a:solidFill>
                   <a:srgbClr val="64748B"/>
                 </a:solidFill>
@@ -27828,7 +27828,7 @@
               </a:spcAft>
             </a:pPr>
             <a:r>
-              <a:rPr sz="900" b="0" i="0">
+              <a:rPr sz="1238" b="0" i="0">
                 <a:solidFill>
                   <a:srgbClr val="64748B"/>
                 </a:solidFill>
@@ -27873,7 +27873,7 @@
               </a:spcAft>
             </a:pPr>
             <a:r>
-              <a:rPr sz="900" b="0" i="0">
+              <a:rPr sz="1238" b="0" i="0">
                 <a:solidFill>
                   <a:srgbClr val="64748B"/>
                 </a:solidFill>
@@ -27980,7 +27980,7 @@
               </a:spcAft>
             </a:pPr>
             <a:r>
-              <a:rPr sz="1250" b="1" i="0">
+              <a:rPr sz="1652" b="1" i="0">
                 <a:solidFill>
                   <a:srgbClr val="2563EB"/>
                 </a:solidFill>
@@ -28205,7 +28205,7 @@
               </a:spcAft>
             </a:pPr>
             <a:r>
-              <a:rPr sz="1600" b="1" i="0">
+              <a:rPr sz="1888" b="1" i="0">
                 <a:solidFill>
                   <a:srgbClr val="0F172A"/>
                 </a:solidFill>
@@ -28250,7 +28250,7 @@
               </a:spcAft>
             </a:pPr>
             <a:r>
-              <a:rPr sz="1150" b="0" i="1">
+              <a:rPr sz="1534" b="0" i="1">
                 <a:solidFill>
                   <a:srgbClr val="64748B"/>
                 </a:solidFill>
@@ -28272,7 +28272,7 @@
               </a:spcAft>
             </a:pPr>
             <a:r>
-              <a:rPr sz="1150" b="0" i="1">
+              <a:rPr sz="1534" b="0" i="1">
                 <a:solidFill>
                   <a:srgbClr val="64748B"/>
                 </a:solidFill>
@@ -28452,7 +28452,7 @@
               </a:spcAft>
             </a:pPr>
             <a:r>
-              <a:rPr sz="1600" b="1" i="0">
+              <a:rPr sz="1888" b="1" i="0">
                 <a:solidFill>
                   <a:srgbClr val="0F172A"/>
                 </a:solidFill>
@@ -28497,7 +28497,7 @@
               </a:spcAft>
             </a:pPr>
             <a:r>
-              <a:rPr sz="1150" b="0" i="1">
+              <a:rPr sz="1534" b="0" i="1">
                 <a:solidFill>
                   <a:srgbClr val="64748B"/>
                 </a:solidFill>
@@ -28519,7 +28519,7 @@
               </a:spcAft>
             </a:pPr>
             <a:r>
-              <a:rPr sz="1150" b="0" i="1">
+              <a:rPr sz="1534" b="0" i="1">
                 <a:solidFill>
                   <a:srgbClr val="64748B"/>
                 </a:solidFill>
@@ -28699,7 +28699,7 @@
               </a:spcAft>
             </a:pPr>
             <a:r>
-              <a:rPr sz="1600" b="1" i="0">
+              <a:rPr sz="1888" b="1" i="0">
                 <a:solidFill>
                   <a:srgbClr val="0F172A"/>
                 </a:solidFill>
@@ -28744,7 +28744,7 @@
               </a:spcAft>
             </a:pPr>
             <a:r>
-              <a:rPr sz="1150" b="0" i="1">
+              <a:rPr sz="1534" b="0" i="1">
                 <a:solidFill>
                   <a:srgbClr val="64748B"/>
                 </a:solidFill>
@@ -28766,7 +28766,7 @@
               </a:spcAft>
             </a:pPr>
             <a:r>
-              <a:rPr sz="1150" b="0" i="1">
+              <a:rPr sz="1534" b="0" i="1">
                 <a:solidFill>
                   <a:srgbClr val="64748B"/>
                 </a:solidFill>
@@ -28811,7 +28811,7 @@
               </a:spcAft>
             </a:pPr>
             <a:r>
-              <a:rPr sz="1500" b="0">
+              <a:rPr sz="1770" b="0">
                 <a:solidFill>
                   <a:srgbClr val="2563EB"/>
                 </a:solidFill>
@@ -28820,7 +28820,7 @@
               <a:t>–  </a:t>
             </a:r>
             <a:r>
-              <a:rPr sz="1500">
+              <a:rPr sz="1770">
                 <a:solidFill>
                   <a:srgbClr val="0F172A"/>
                 </a:solidFill>
@@ -28842,7 +28842,7 @@
               </a:spcAft>
             </a:pPr>
             <a:r>
-              <a:rPr sz="1500" b="0">
+              <a:rPr sz="1770" b="0">
                 <a:solidFill>
                   <a:srgbClr val="2563EB"/>
                 </a:solidFill>
@@ -28851,7 +28851,7 @@
               <a:t>–  </a:t>
             </a:r>
             <a:r>
-              <a:rPr sz="1500">
+              <a:rPr sz="1770">
                 <a:solidFill>
                   <a:srgbClr val="0F172A"/>
                 </a:solidFill>
@@ -28873,7 +28873,7 @@
               </a:spcAft>
             </a:pPr>
             <a:r>
-              <a:rPr sz="1500" b="0">
+              <a:rPr sz="1770" b="0">
                 <a:solidFill>
                   <a:srgbClr val="2563EB"/>
                 </a:solidFill>
@@ -28882,7 +28882,7 @@
               <a:t>–  </a:t>
             </a:r>
             <a:r>
-              <a:rPr sz="1500">
+              <a:rPr sz="1770">
                 <a:solidFill>
                   <a:srgbClr val="0F172A"/>
                 </a:solidFill>
@@ -28927,7 +28927,7 @@
               </a:spcAft>
             </a:pPr>
             <a:r>
-              <a:rPr sz="950" b="0" i="1">
+              <a:rPr sz="1297" b="0" i="1">
                 <a:solidFill>
                   <a:srgbClr val="64748B"/>
                 </a:solidFill>
@@ -28972,7 +28972,7 @@
               </a:spcAft>
             </a:pPr>
             <a:r>
-              <a:rPr sz="900" b="0" i="0">
+              <a:rPr sz="1238" b="0" i="0">
                 <a:solidFill>
                   <a:srgbClr val="64748B"/>
                 </a:solidFill>
@@ -29017,7 +29017,7 @@
               </a:spcAft>
             </a:pPr>
             <a:r>
-              <a:rPr sz="900" b="0" i="0">
+              <a:rPr sz="1238" b="0" i="0">
                 <a:solidFill>
                   <a:srgbClr val="64748B"/>
                 </a:solidFill>
@@ -29124,7 +29124,7 @@
               </a:spcAft>
             </a:pPr>
             <a:r>
-              <a:rPr sz="1250" b="1" i="0">
+              <a:rPr sz="1652" b="1" i="0">
                 <a:solidFill>
                   <a:srgbClr val="2563EB"/>
                 </a:solidFill>
@@ -29258,7 +29258,7 @@
               </a:spcAft>
             </a:pPr>
             <a:r>
-              <a:rPr sz="1300" b="1" i="0">
+              <a:rPr sz="1652" b="1" i="0">
                 <a:solidFill>
                   <a:srgbClr val="FFFFFF"/>
                 </a:solidFill>
@@ -29347,7 +29347,7 @@
               </a:spcAft>
             </a:pPr>
             <a:r>
-              <a:rPr sz="1300" b="1" i="0">
+              <a:rPr sz="1652" b="1" i="0">
                 <a:solidFill>
                   <a:srgbClr val="FFFFFF"/>
                 </a:solidFill>
@@ -29436,7 +29436,7 @@
               </a:spcAft>
             </a:pPr>
             <a:r>
-              <a:rPr sz="1300" b="1" i="0">
+              <a:rPr sz="1652" b="1" i="0">
                 <a:solidFill>
                   <a:srgbClr val="FFFFFF"/>
                 </a:solidFill>
@@ -29525,7 +29525,7 @@
               </a:spcAft>
             </a:pPr>
             <a:r>
-              <a:rPr sz="1300" b="1" i="0">
+              <a:rPr sz="1652" b="1" i="0">
                 <a:solidFill>
                   <a:srgbClr val="FFFFFF"/>
                 </a:solidFill>
@@ -29616,7 +29616,7 @@
               </a:spcAft>
             </a:pPr>
             <a:r>
-              <a:rPr sz="1250" b="1" i="0">
+              <a:rPr sz="1593" b="1" i="0">
                 <a:solidFill>
                   <a:srgbClr val="0F172A"/>
                 </a:solidFill>
@@ -29707,7 +29707,7 @@
               </a:spcAft>
             </a:pPr>
             <a:r>
-              <a:rPr sz="1250" b="0" i="0">
+              <a:rPr sz="1593" b="0" i="0">
                 <a:solidFill>
                   <a:srgbClr val="0F172A"/>
                 </a:solidFill>
@@ -29798,7 +29798,7 @@
               </a:spcAft>
             </a:pPr>
             <a:r>
-              <a:rPr sz="1250" b="0" i="0">
+              <a:rPr sz="1593" b="0" i="0">
                 <a:solidFill>
                   <a:srgbClr val="0F172A"/>
                 </a:solidFill>
@@ -29889,7 +29889,7 @@
               </a:spcAft>
             </a:pPr>
             <a:r>
-              <a:rPr sz="1250" b="0" i="0">
+              <a:rPr sz="1593" b="0" i="0">
                 <a:solidFill>
                   <a:srgbClr val="0F172A"/>
                 </a:solidFill>
@@ -29980,7 +29980,7 @@
               </a:spcAft>
             </a:pPr>
             <a:r>
-              <a:rPr sz="1250" b="1" i="0">
+              <a:rPr sz="1593" b="1" i="0">
                 <a:solidFill>
                   <a:srgbClr val="0F172A"/>
                 </a:solidFill>
@@ -30071,7 +30071,7 @@
               </a:spcAft>
             </a:pPr>
             <a:r>
-              <a:rPr sz="1250" b="0" i="0">
+              <a:rPr sz="1593" b="0" i="0">
                 <a:solidFill>
                   <a:srgbClr val="0F172A"/>
                 </a:solidFill>
@@ -30162,7 +30162,7 @@
               </a:spcAft>
             </a:pPr>
             <a:r>
-              <a:rPr sz="1250" b="0" i="0">
+              <a:rPr sz="1593" b="0" i="0">
                 <a:solidFill>
                   <a:srgbClr val="0F172A"/>
                 </a:solidFill>
@@ -30253,7 +30253,7 @@
               </a:spcAft>
             </a:pPr>
             <a:r>
-              <a:rPr sz="1250" b="0" i="0">
+              <a:rPr sz="1593" b="0" i="0">
                 <a:solidFill>
                   <a:srgbClr val="0F172A"/>
                 </a:solidFill>
@@ -30344,7 +30344,7 @@
               </a:spcAft>
             </a:pPr>
             <a:r>
-              <a:rPr sz="1250" b="1" i="0">
+              <a:rPr sz="1593" b="1" i="0">
                 <a:solidFill>
                   <a:srgbClr val="0F172A"/>
                 </a:solidFill>
@@ -30435,7 +30435,7 @@
               </a:spcAft>
             </a:pPr>
             <a:r>
-              <a:rPr sz="1250" b="0" i="0">
+              <a:rPr sz="1593" b="0" i="0">
                 <a:solidFill>
                   <a:srgbClr val="0F172A"/>
                 </a:solidFill>
@@ -30526,7 +30526,7 @@
               </a:spcAft>
             </a:pPr>
             <a:r>
-              <a:rPr sz="1250" b="0" i="0">
+              <a:rPr sz="1593" b="0" i="0">
                 <a:solidFill>
                   <a:srgbClr val="0F172A"/>
                 </a:solidFill>
@@ -30617,7 +30617,7 @@
               </a:spcAft>
             </a:pPr>
             <a:r>
-              <a:rPr sz="1250" b="0" i="0">
+              <a:rPr sz="1593" b="0" i="0">
                 <a:solidFill>
                   <a:srgbClr val="0F172A"/>
                 </a:solidFill>
@@ -30708,7 +30708,7 @@
               </a:spcAft>
             </a:pPr>
             <a:r>
-              <a:rPr sz="1250" b="1" i="0">
+              <a:rPr sz="1593" b="1" i="0">
                 <a:solidFill>
                   <a:srgbClr val="0F172A"/>
                 </a:solidFill>
@@ -30799,7 +30799,7 @@
               </a:spcAft>
             </a:pPr>
             <a:r>
-              <a:rPr sz="1250" b="0" i="0">
+              <a:rPr sz="1593" b="0" i="0">
                 <a:solidFill>
                   <a:srgbClr val="0F172A"/>
                 </a:solidFill>
@@ -30890,7 +30890,7 @@
               </a:spcAft>
             </a:pPr>
             <a:r>
-              <a:rPr sz="1250" b="0" i="0">
+              <a:rPr sz="1593" b="0" i="0">
                 <a:solidFill>
                   <a:srgbClr val="0F172A"/>
                 </a:solidFill>
@@ -30981,7 +30981,7 @@
               </a:spcAft>
             </a:pPr>
             <a:r>
-              <a:rPr sz="1250" b="0" i="0">
+              <a:rPr sz="1593" b="0" i="0">
                 <a:solidFill>
                   <a:srgbClr val="0F172A"/>
                 </a:solidFill>
@@ -31072,7 +31072,7 @@
               </a:spcAft>
             </a:pPr>
             <a:r>
-              <a:rPr sz="1250" b="1" i="0">
+              <a:rPr sz="1593" b="1" i="0">
                 <a:solidFill>
                   <a:srgbClr val="0F172A"/>
                 </a:solidFill>
@@ -31163,7 +31163,7 @@
               </a:spcAft>
             </a:pPr>
             <a:r>
-              <a:rPr sz="1250" b="0" i="0">
+              <a:rPr sz="1593" b="0" i="0">
                 <a:solidFill>
                   <a:srgbClr val="0F172A"/>
                 </a:solidFill>
@@ -31254,7 +31254,7 @@
               </a:spcAft>
             </a:pPr>
             <a:r>
-              <a:rPr sz="1250" b="0" i="0">
+              <a:rPr sz="1593" b="0" i="0">
                 <a:solidFill>
                   <a:srgbClr val="0F172A"/>
                 </a:solidFill>
@@ -31345,7 +31345,7 @@
               </a:spcAft>
             </a:pPr>
             <a:r>
-              <a:rPr sz="1250" b="0" i="0">
+              <a:rPr sz="1593" b="0" i="0">
                 <a:solidFill>
                   <a:srgbClr val="0F172A"/>
                 </a:solidFill>
@@ -31436,7 +31436,7 @@
               </a:spcAft>
             </a:pPr>
             <a:r>
-              <a:rPr sz="1250" b="1" i="0">
+              <a:rPr sz="1593" b="1" i="0">
                 <a:solidFill>
                   <a:srgbClr val="0F172A"/>
                 </a:solidFill>
@@ -31527,7 +31527,7 @@
               </a:spcAft>
             </a:pPr>
             <a:r>
-              <a:rPr sz="1250" b="0" i="0">
+              <a:rPr sz="1593" b="0" i="0">
                 <a:solidFill>
                   <a:srgbClr val="0F172A"/>
                 </a:solidFill>
@@ -31618,7 +31618,7 @@
               </a:spcAft>
             </a:pPr>
             <a:r>
-              <a:rPr sz="1250" b="0" i="0">
+              <a:rPr sz="1593" b="0" i="0">
                 <a:solidFill>
                   <a:srgbClr val="0F172A"/>
                 </a:solidFill>
@@ -31709,7 +31709,7 @@
               </a:spcAft>
             </a:pPr>
             <a:r>
-              <a:rPr sz="1250" b="0" i="0">
+              <a:rPr sz="1593" b="0" i="0">
                 <a:solidFill>
                   <a:srgbClr val="0F172A"/>
                 </a:solidFill>
@@ -31800,7 +31800,7 @@
               </a:spcAft>
             </a:pPr>
             <a:r>
-              <a:rPr sz="1250" b="1" i="0">
+              <a:rPr sz="1593" b="1" i="0">
                 <a:solidFill>
                   <a:srgbClr val="0F172A"/>
                 </a:solidFill>
@@ -31891,7 +31891,7 @@
               </a:spcAft>
             </a:pPr>
             <a:r>
-              <a:rPr sz="1250" b="0" i="0">
+              <a:rPr sz="1593" b="0" i="0">
                 <a:solidFill>
                   <a:srgbClr val="0F172A"/>
                 </a:solidFill>
@@ -31982,7 +31982,7 @@
               </a:spcAft>
             </a:pPr>
             <a:r>
-              <a:rPr sz="1250" b="0" i="0">
+              <a:rPr sz="1593" b="0" i="0">
                 <a:solidFill>
                   <a:srgbClr val="0F172A"/>
                 </a:solidFill>
@@ -32073,7 +32073,7 @@
               </a:spcAft>
             </a:pPr>
             <a:r>
-              <a:rPr sz="1250" b="0" i="0">
+              <a:rPr sz="1593" b="0" i="0">
                 <a:solidFill>
                   <a:srgbClr val="0F172A"/>
                 </a:solidFill>
@@ -32162,7 +32162,7 @@
               </a:spcAft>
             </a:pPr>
             <a:r>
-              <a:rPr sz="1300" b="1" i="0">
+              <a:rPr sz="1534" b="1" i="0">
                 <a:solidFill>
                   <a:srgbClr val="FFFFFF"/>
                 </a:solidFill>
@@ -32251,7 +32251,7 @@
               </a:spcAft>
             </a:pPr>
             <a:r>
-              <a:rPr sz="1300" b="1" i="0">
+              <a:rPr sz="1534" b="1" i="0">
                 <a:solidFill>
                   <a:srgbClr val="FFFFFF"/>
                 </a:solidFill>
@@ -32340,7 +32340,7 @@
               </a:spcAft>
             </a:pPr>
             <a:r>
-              <a:rPr sz="1300" b="1" i="0">
+              <a:rPr sz="1534" b="1" i="0">
                 <a:solidFill>
                   <a:srgbClr val="FFFFFF"/>
                 </a:solidFill>
@@ -32385,7 +32385,7 @@
               </a:spcAft>
             </a:pPr>
             <a:r>
-              <a:rPr sz="1300" b="1" i="0">
+              <a:rPr sz="1534" b="1" i="0">
                 <a:solidFill>
                   <a:srgbClr val="0F172A"/>
                 </a:solidFill>
@@ -32430,7 +32430,7 @@
               </a:spcAft>
             </a:pPr>
             <a:r>
-              <a:rPr sz="950" b="0" i="1">
+              <a:rPr sz="1297" b="0" i="1">
                 <a:solidFill>
                   <a:srgbClr val="64748B"/>
                 </a:solidFill>
@@ -32475,7 +32475,7 @@
               </a:spcAft>
             </a:pPr>
             <a:r>
-              <a:rPr sz="900" b="0" i="0">
+              <a:rPr sz="1238" b="0" i="0">
                 <a:solidFill>
                   <a:srgbClr val="64748B"/>
                 </a:solidFill>
@@ -32520,7 +32520,7 @@
               </a:spcAft>
             </a:pPr>
             <a:r>
-              <a:rPr sz="900" b="0" i="0">
+              <a:rPr sz="1238" b="0" i="0">
                 <a:solidFill>
                   <a:srgbClr val="64748B"/>
                 </a:solidFill>
@@ -32627,7 +32627,7 @@
               </a:spcAft>
             </a:pPr>
             <a:r>
-              <a:rPr sz="1250" b="1" i="0">
+              <a:rPr sz="1652" b="1" i="0">
                 <a:solidFill>
                   <a:srgbClr val="2563EB"/>
                 </a:solidFill>
@@ -32782,7 +32782,7 @@
         <p:spPr>
           <a:xfrm>
             <a:off x="713232" y="1892808"/>
-            <a:ext cx="3264408" cy="365760"/>
+            <a:ext cx="3264408" cy="548640"/>
           </a:xfrm>
           <a:prstGeom prst="rect">
             <a:avLst/>
@@ -32797,7 +32797,7 @@
           <a:p>
             <a:pPr algn="l">
               <a:lnSpc>
-                <a:spcPct val="100000"/>
+                <a:spcPct val="98000"/>
               </a:lnSpc>
               <a:spcBef>
                 <a:spcPts val="0"/>
@@ -32807,7 +32807,7 @@
               </a:spcAft>
             </a:pPr>
             <a:r>
-              <a:rPr sz="1500" b="1" i="0">
+              <a:rPr sz="1888" b="1" i="0">
                 <a:solidFill>
                   <a:srgbClr val="DC2626"/>
                 </a:solidFill>
@@ -32826,8 +32826,8 @@
         </p:nvSpPr>
         <p:spPr>
           <a:xfrm>
-            <a:off x="713232" y="2350008"/>
-            <a:ext cx="3264408" cy="2514600"/>
+            <a:off x="713232" y="2478024"/>
+            <a:ext cx="3264408" cy="2386584"/>
           </a:xfrm>
           <a:prstGeom prst="rect">
             <a:avLst/>
@@ -32852,7 +32852,7 @@
               </a:spcAft>
             </a:pPr>
             <a:r>
-              <a:rPr sz="1200" b="0">
+              <a:rPr sz="1593" b="0">
                 <a:solidFill>
                   <a:srgbClr val="DC2626"/>
                 </a:solidFill>
@@ -32861,7 +32861,7 @@
               <a:t>–  </a:t>
             </a:r>
             <a:r>
-              <a:rPr sz="1200">
+              <a:rPr sz="1593">
                 <a:solidFill>
                   <a:srgbClr val="0F172A"/>
                 </a:solidFill>
@@ -32883,7 +32883,7 @@
               </a:spcAft>
             </a:pPr>
             <a:r>
-              <a:rPr sz="1200" b="0">
+              <a:rPr sz="1593" b="0">
                 <a:solidFill>
                   <a:srgbClr val="DC2626"/>
                 </a:solidFill>
@@ -32892,7 +32892,7 @@
               <a:t>–  </a:t>
             </a:r>
             <a:r>
-              <a:rPr sz="1200">
+              <a:rPr sz="1593">
                 <a:solidFill>
                   <a:srgbClr val="0F172A"/>
                 </a:solidFill>
@@ -32914,7 +32914,7 @@
               </a:spcAft>
             </a:pPr>
             <a:r>
-              <a:rPr sz="1200" b="0">
+              <a:rPr sz="1593" b="0">
                 <a:solidFill>
                   <a:srgbClr val="DC2626"/>
                 </a:solidFill>
@@ -32923,7 +32923,7 @@
               <a:t>–  </a:t>
             </a:r>
             <a:r>
-              <a:rPr sz="1200">
+              <a:rPr sz="1593">
                 <a:solidFill>
                   <a:srgbClr val="0F172A"/>
                 </a:solidFill>
@@ -32945,7 +32945,7 @@
               </a:spcAft>
             </a:pPr>
             <a:r>
-              <a:rPr sz="1200" b="0">
+              <a:rPr sz="1593" b="0">
                 <a:solidFill>
                   <a:srgbClr val="DC2626"/>
                 </a:solidFill>
@@ -32954,7 +32954,7 @@
               <a:t>–  </a:t>
             </a:r>
             <a:r>
-              <a:rPr sz="1200">
+              <a:rPr sz="1593">
                 <a:solidFill>
                   <a:srgbClr val="0F172A"/>
                 </a:solidFill>
@@ -33064,7 +33064,7 @@
         <p:spPr>
           <a:xfrm>
             <a:off x="4443984" y="1892808"/>
-            <a:ext cx="3264408" cy="365760"/>
+            <a:ext cx="3264408" cy="548640"/>
           </a:xfrm>
           <a:prstGeom prst="rect">
             <a:avLst/>
@@ -33079,7 +33079,7 @@
           <a:p>
             <a:pPr algn="l">
               <a:lnSpc>
-                <a:spcPct val="100000"/>
+                <a:spcPct val="98000"/>
               </a:lnSpc>
               <a:spcBef>
                 <a:spcPts val="0"/>
@@ -33089,7 +33089,7 @@
               </a:spcAft>
             </a:pPr>
             <a:r>
-              <a:rPr sz="1500" b="1" i="0">
+              <a:rPr sz="1888" b="1" i="0">
                 <a:solidFill>
                   <a:srgbClr val="2563EB"/>
                 </a:solidFill>
@@ -33108,8 +33108,8 @@
         </p:nvSpPr>
         <p:spPr>
           <a:xfrm>
-            <a:off x="4443984" y="2350008"/>
-            <a:ext cx="3264408" cy="2514600"/>
+            <a:off x="4443984" y="2478024"/>
+            <a:ext cx="3264408" cy="2386584"/>
           </a:xfrm>
           <a:prstGeom prst="rect">
             <a:avLst/>
@@ -33134,7 +33134,7 @@
               </a:spcAft>
             </a:pPr>
             <a:r>
-              <a:rPr sz="1200" b="0">
+              <a:rPr sz="1593" b="0">
                 <a:solidFill>
                   <a:srgbClr val="2563EB"/>
                 </a:solidFill>
@@ -33143,7 +33143,7 @@
               <a:t>–  </a:t>
             </a:r>
             <a:r>
-              <a:rPr sz="1200">
+              <a:rPr sz="1593">
                 <a:solidFill>
                   <a:srgbClr val="0F172A"/>
                 </a:solidFill>
@@ -33165,7 +33165,7 @@
               </a:spcAft>
             </a:pPr>
             <a:r>
-              <a:rPr sz="1200" b="0">
+              <a:rPr sz="1593" b="0">
                 <a:solidFill>
                   <a:srgbClr val="2563EB"/>
                 </a:solidFill>
@@ -33174,7 +33174,7 @@
               <a:t>–  </a:t>
             </a:r>
             <a:r>
-              <a:rPr sz="1200">
+              <a:rPr sz="1593">
                 <a:solidFill>
                   <a:srgbClr val="0F172A"/>
                 </a:solidFill>
@@ -33196,7 +33196,7 @@
               </a:spcAft>
             </a:pPr>
             <a:r>
-              <a:rPr sz="1200" b="0">
+              <a:rPr sz="1593" b="0">
                 <a:solidFill>
                   <a:srgbClr val="2563EB"/>
                 </a:solidFill>
@@ -33205,7 +33205,7 @@
               <a:t>–  </a:t>
             </a:r>
             <a:r>
-              <a:rPr sz="1200">
+              <a:rPr sz="1593">
                 <a:solidFill>
                   <a:srgbClr val="0F172A"/>
                 </a:solidFill>
@@ -33227,7 +33227,7 @@
               </a:spcAft>
             </a:pPr>
             <a:r>
-              <a:rPr sz="1200" b="0">
+              <a:rPr sz="1593" b="0">
                 <a:solidFill>
                   <a:srgbClr val="2563EB"/>
                 </a:solidFill>
@@ -33236,7 +33236,7 @@
               <a:t>–  </a:t>
             </a:r>
             <a:r>
-              <a:rPr sz="1200">
+              <a:rPr sz="1593">
                 <a:solidFill>
                   <a:srgbClr val="0F172A"/>
                 </a:solidFill>
@@ -33346,7 +33346,7 @@
         <p:spPr>
           <a:xfrm>
             <a:off x="8174736" y="1892808"/>
-            <a:ext cx="3264408" cy="365760"/>
+            <a:ext cx="3264408" cy="548640"/>
           </a:xfrm>
           <a:prstGeom prst="rect">
             <a:avLst/>
@@ -33361,7 +33361,7 @@
           <a:p>
             <a:pPr algn="l">
               <a:lnSpc>
-                <a:spcPct val="100000"/>
+                <a:spcPct val="98000"/>
               </a:lnSpc>
               <a:spcBef>
                 <a:spcPts val="0"/>
@@ -33371,7 +33371,7 @@
               </a:spcAft>
             </a:pPr>
             <a:r>
-              <a:rPr sz="1500" b="1" i="0">
+              <a:rPr sz="1888" b="1" i="0">
                 <a:solidFill>
                   <a:srgbClr val="06B6D4"/>
                 </a:solidFill>
@@ -33390,8 +33390,8 @@
         </p:nvSpPr>
         <p:spPr>
           <a:xfrm>
-            <a:off x="8174736" y="2350008"/>
-            <a:ext cx="3264408" cy="2514600"/>
+            <a:off x="8174736" y="2478024"/>
+            <a:ext cx="3264408" cy="2386584"/>
           </a:xfrm>
           <a:prstGeom prst="rect">
             <a:avLst/>
@@ -33416,7 +33416,7 @@
               </a:spcAft>
             </a:pPr>
             <a:r>
-              <a:rPr sz="1200" b="0">
+              <a:rPr sz="1593" b="0">
                 <a:solidFill>
                   <a:srgbClr val="06B6D4"/>
                 </a:solidFill>
@@ -33425,7 +33425,7 @@
               <a:t>–  </a:t>
             </a:r>
             <a:r>
-              <a:rPr sz="1200">
+              <a:rPr sz="1593">
                 <a:solidFill>
                   <a:srgbClr val="0F172A"/>
                 </a:solidFill>
@@ -33447,7 +33447,7 @@
               </a:spcAft>
             </a:pPr>
             <a:r>
-              <a:rPr sz="1200" b="0">
+              <a:rPr sz="1593" b="0">
                 <a:solidFill>
                   <a:srgbClr val="06B6D4"/>
                 </a:solidFill>
@@ -33456,7 +33456,7 @@
               <a:t>–  </a:t>
             </a:r>
             <a:r>
-              <a:rPr sz="1200">
+              <a:rPr sz="1593">
                 <a:solidFill>
                   <a:srgbClr val="0F172A"/>
                 </a:solidFill>
@@ -33478,7 +33478,7 @@
               </a:spcAft>
             </a:pPr>
             <a:r>
-              <a:rPr sz="1200" b="0">
+              <a:rPr sz="1593" b="0">
                 <a:solidFill>
                   <a:srgbClr val="06B6D4"/>
                 </a:solidFill>
@@ -33487,7 +33487,7 @@
               <a:t>–  </a:t>
             </a:r>
             <a:r>
-              <a:rPr sz="1200">
+              <a:rPr sz="1593">
                 <a:solidFill>
                   <a:srgbClr val="0F172A"/>
                 </a:solidFill>
@@ -33509,7 +33509,7 @@
               </a:spcAft>
             </a:pPr>
             <a:r>
-              <a:rPr sz="1200" b="0">
+              <a:rPr sz="1593" b="0">
                 <a:solidFill>
                   <a:srgbClr val="06B6D4"/>
                 </a:solidFill>
@@ -33518,7 +33518,7 @@
               <a:t>–  </a:t>
             </a:r>
             <a:r>
-              <a:rPr sz="1200">
+              <a:rPr sz="1593">
                 <a:solidFill>
                   <a:srgbClr val="0F172A"/>
                 </a:solidFill>
@@ -33607,7 +33607,7 @@
               </a:spcAft>
             </a:pPr>
             <a:r>
-              <a:rPr sz="1350" b="1" i="0">
+              <a:rPr sz="1593" b="1" i="0">
                 <a:solidFill>
                   <a:srgbClr val="FFFFFF"/>
                 </a:solidFill>
@@ -33652,7 +33652,7 @@
               </a:spcAft>
             </a:pPr>
             <a:r>
-              <a:rPr sz="900" b="0" i="0">
+              <a:rPr sz="1238" b="0" i="0">
                 <a:solidFill>
                   <a:srgbClr val="64748B"/>
                 </a:solidFill>
@@ -33697,7 +33697,7 @@
               </a:spcAft>
             </a:pPr>
             <a:r>
-              <a:rPr sz="900" b="0" i="0">
+              <a:rPr sz="1238" b="0" i="0">
                 <a:solidFill>
                   <a:srgbClr val="64748B"/>
                 </a:solidFill>

</xml_diff>